<commit_message>
Update Digital Twin Server Project presentation
Revised the Digital_Twin_Server_Project.pptx file with new or updated content. See the presentation for specific changes.
</commit_message>
<xml_diff>
--- a/Presentation/Digital_Twin_Server_Project.pptx
+++ b/Presentation/Digital_Twin_Server_Project.pptx
@@ -5,10 +5,10 @@
     <p:sldMasterId id="2147483648" r:id="rId4"/>
   </p:sldMasterIdLst>
   <p:notesMasterIdLst>
-    <p:notesMasterId r:id="rId21"/>
+    <p:notesMasterId r:id="rId19"/>
   </p:notesMasterIdLst>
   <p:handoutMasterIdLst>
-    <p:handoutMasterId r:id="rId22"/>
+    <p:handoutMasterId r:id="rId20"/>
   </p:handoutMasterIdLst>
   <p:sldIdLst>
     <p:sldId id="289" r:id="rId5"/>
@@ -19,14 +19,12 @@
     <p:sldId id="257" r:id="rId10"/>
     <p:sldId id="264" r:id="rId11"/>
     <p:sldId id="265" r:id="rId12"/>
-    <p:sldId id="263" r:id="rId13"/>
-    <p:sldId id="292" r:id="rId14"/>
-    <p:sldId id="291" r:id="rId15"/>
-    <p:sldId id="268" r:id="rId16"/>
-    <p:sldId id="266" r:id="rId17"/>
-    <p:sldId id="267" r:id="rId18"/>
-    <p:sldId id="290" r:id="rId19"/>
-    <p:sldId id="262" r:id="rId20"/>
+    <p:sldId id="292" r:id="rId13"/>
+    <p:sldId id="291" r:id="rId14"/>
+    <p:sldId id="268" r:id="rId15"/>
+    <p:sldId id="266" r:id="rId16"/>
+    <p:sldId id="267" r:id="rId17"/>
+    <p:sldId id="262" r:id="rId18"/>
   </p:sldIdLst>
   <p:sldSz cx="12192000" cy="6858000"/>
   <p:notesSz cx="6858000" cy="9144000"/>
@@ -835,7 +833,7 @@
             <a:pPr rtl="0"/>
             <a:fld id="{CC5DA344-5FA2-43F7-9D95-CA56C82B080A}" type="slidenum">
               <a:rPr lang="es-ES" smtClean="0"/>
-              <a:t>12</a:t>
+              <a:t>11</a:t>
             </a:fld>
             <a:endParaRPr lang="es-ES"/>
           </a:p>
@@ -929,7 +927,7 @@
             <a:pPr rtl="0"/>
             <a:fld id="{CC5DA344-5FA2-43F7-9D95-CA56C82B080A}" type="slidenum">
               <a:rPr lang="es-ES" smtClean="0"/>
-              <a:t>13</a:t>
+              <a:t>12</a:t>
             </a:fld>
             <a:endParaRPr lang="es-ES"/>
           </a:p>
@@ -1023,7 +1021,7 @@
             <a:pPr rtl="0"/>
             <a:fld id="{CC5DA344-5FA2-43F7-9D95-CA56C82B080A}" type="slidenum">
               <a:rPr lang="es-ES" smtClean="0"/>
-              <a:t>14</a:t>
+              <a:t>13</a:t>
             </a:fld>
             <a:endParaRPr lang="es-ES"/>
           </a:p>
@@ -1043,124 +1041,6 @@
 </file>
 
 <file path=ppt/notesSlides/notesSlide13.xml><?xml version="1.0" encoding="utf-8"?>
-<p:notes xmlns:a="http://schemas.openxmlformats.org/drawingml/2006/main" xmlns:r="http://schemas.openxmlformats.org/officeDocument/2006/relationships" xmlns:p="http://schemas.openxmlformats.org/presentationml/2006/main">
-  <p:cSld>
-    <p:spTree>
-      <p:nvGrpSpPr>
-        <p:cNvPr id="1" name="">
-          <a:extLst>
-            <a:ext uri="{FF2B5EF4-FFF2-40B4-BE49-F238E27FC236}">
-              <a16:creationId xmlns:a16="http://schemas.microsoft.com/office/drawing/2014/main" id="{0A4C7C52-CD9C-3777-93D1-4A7982E7AC06}"/>
-            </a:ext>
-          </a:extLst>
-        </p:cNvPr>
-        <p:cNvGrpSpPr/>
-        <p:nvPr/>
-      </p:nvGrpSpPr>
-      <p:grpSpPr>
-        <a:xfrm>
-          <a:off x="0" y="0"/>
-          <a:ext cx="0" cy="0"/>
-          <a:chOff x="0" y="0"/>
-          <a:chExt cx="0" cy="0"/>
-        </a:xfrm>
-      </p:grpSpPr>
-      <p:sp>
-        <p:nvSpPr>
-          <p:cNvPr id="2" name="Marcador de imagen de diapositiva 1">
-            <a:extLst>
-              <a:ext uri="{FF2B5EF4-FFF2-40B4-BE49-F238E27FC236}">
-                <a16:creationId xmlns:a16="http://schemas.microsoft.com/office/drawing/2014/main" id="{6EA67FED-2777-8AD0-0F6D-54E182569546}"/>
-              </a:ext>
-            </a:extLst>
-          </p:cNvPr>
-          <p:cNvSpPr>
-            <a:spLocks noGrp="1" noRot="1" noChangeAspect="1"/>
-          </p:cNvSpPr>
-          <p:nvPr>
-            <p:ph type="sldImg"/>
-          </p:nvPr>
-        </p:nvSpPr>
-        <p:spPr/>
-      </p:sp>
-      <p:sp>
-        <p:nvSpPr>
-          <p:cNvPr id="3" name="Marcador de notas 2">
-            <a:extLst>
-              <a:ext uri="{FF2B5EF4-FFF2-40B4-BE49-F238E27FC236}">
-                <a16:creationId xmlns:a16="http://schemas.microsoft.com/office/drawing/2014/main" id="{E859842E-75D0-07B1-F284-4015A74D4851}"/>
-              </a:ext>
-            </a:extLst>
-          </p:cNvPr>
-          <p:cNvSpPr>
-            <a:spLocks noGrp="1"/>
-          </p:cNvSpPr>
-          <p:nvPr>
-            <p:ph type="body" idx="1"/>
-          </p:nvPr>
-        </p:nvSpPr>
-        <p:spPr/>
-        <p:txBody>
-          <a:bodyPr rtlCol="0"/>
-          <a:lstStyle>
-            <a:defPPr>
-              <a:defRPr lang="es-ES"/>
-            </a:defPPr>
-          </a:lstStyle>
-          <a:p>
-            <a:pPr rtl="0"/>
-            <a:endParaRPr lang="es-ES" dirty="0"/>
-          </a:p>
-        </p:txBody>
-      </p:sp>
-      <p:sp>
-        <p:nvSpPr>
-          <p:cNvPr id="4" name="Marcador de número de diapositiva 3">
-            <a:extLst>
-              <a:ext uri="{FF2B5EF4-FFF2-40B4-BE49-F238E27FC236}">
-                <a16:creationId xmlns:a16="http://schemas.microsoft.com/office/drawing/2014/main" id="{4D18B04E-B4D6-BF93-8953-B9DFE445F252}"/>
-              </a:ext>
-            </a:extLst>
-          </p:cNvPr>
-          <p:cNvSpPr>
-            <a:spLocks noGrp="1"/>
-          </p:cNvSpPr>
-          <p:nvPr>
-            <p:ph type="sldNum" sz="quarter" idx="5"/>
-          </p:nvPr>
-        </p:nvSpPr>
-        <p:spPr/>
-        <p:txBody>
-          <a:bodyPr rtlCol="0"/>
-          <a:lstStyle>
-            <a:defPPr>
-              <a:defRPr lang="es-ES"/>
-            </a:defPPr>
-          </a:lstStyle>
-          <a:p>
-            <a:pPr rtl="0"/>
-            <a:fld id="{CC5DA344-5FA2-43F7-9D95-CA56C82B080A}" type="slidenum">
-              <a:rPr lang="es-ES" smtClean="0"/>
-              <a:t>15</a:t>
-            </a:fld>
-            <a:endParaRPr lang="es-ES"/>
-          </a:p>
-        </p:txBody>
-      </p:sp>
-    </p:spTree>
-    <p:extLst>
-      <p:ext uri="{BB962C8B-B14F-4D97-AF65-F5344CB8AC3E}">
-        <p14:creationId xmlns:p14="http://schemas.microsoft.com/office/powerpoint/2010/main" val="3535550999"/>
-      </p:ext>
-    </p:extLst>
-  </p:cSld>
-  <p:clrMapOvr>
-    <a:masterClrMapping/>
-  </p:clrMapOvr>
-</p:notes>
-</file>
-
-<file path=ppt/notesSlides/notesSlide14.xml><?xml version="1.0" encoding="utf-8"?>
 <p:notes xmlns:a="http://schemas.openxmlformats.org/drawingml/2006/main" xmlns:r="http://schemas.openxmlformats.org/officeDocument/2006/relationships" xmlns:p="http://schemas.openxmlformats.org/presentationml/2006/main">
   <p:cSld>
     <p:spTree>
@@ -1235,7 +1115,7 @@
             <a:pPr rtl="0"/>
             <a:fld id="{CC5DA344-5FA2-43F7-9D95-CA56C82B080A}" type="slidenum">
               <a:rPr lang="es-ES" smtClean="0"/>
-              <a:t>16</a:t>
+              <a:t>14</a:t>
             </a:fld>
             <a:endParaRPr lang="es-ES"/>
           </a:p>
@@ -1953,15 +1833,10 @@
         </p:nvSpPr>
         <p:spPr/>
         <p:txBody>
-          <a:bodyPr rtlCol="0"/>
-          <a:lstStyle>
-            <a:defPPr>
-              <a:defRPr lang="es-ES"/>
-            </a:defPPr>
-          </a:lstStyle>
-          <a:p>
-            <a:pPr rtl="0"/>
-            <a:endParaRPr lang="es-ES" dirty="0"/>
+          <a:bodyPr/>
+          <a:lstStyle/>
+          <a:p>
+            <a:endParaRPr lang="es-MX" dirty="0"/>
           </a:p>
         </p:txBody>
       </p:sp>
@@ -1977,12 +1852,8 @@
         </p:nvSpPr>
         <p:spPr/>
         <p:txBody>
-          <a:bodyPr rtlCol="0"/>
-          <a:lstStyle>
-            <a:defPPr>
-              <a:defRPr lang="es-ES"/>
-            </a:defPPr>
-          </a:lstStyle>
+          <a:bodyPr/>
+          <a:lstStyle/>
           <a:p>
             <a:pPr rtl="0"/>
             <a:fld id="{CC5DA344-5FA2-43F7-9D95-CA56C82B080A}" type="slidenum">
@@ -1996,7 +1867,7 @@
     </p:spTree>
     <p:extLst>
       <p:ext uri="{BB962C8B-B14F-4D97-AF65-F5344CB8AC3E}">
-        <p14:creationId xmlns:p14="http://schemas.microsoft.com/office/powerpoint/2010/main" val="206508376"/>
+        <p14:creationId xmlns:p14="http://schemas.microsoft.com/office/powerpoint/2010/main" val="4002194968"/>
       </p:ext>
     </p:extLst>
   </p:cSld>
@@ -9796,304 +9667,7 @@
 </file>
 
 <file path=ppt/slides/slide10.xml><?xml version="1.0" encoding="utf-8"?>
-<p:sld xmlns:a="http://schemas.openxmlformats.org/drawingml/2006/main" xmlns:r="http://schemas.openxmlformats.org/officeDocument/2006/relationships" xmlns:p="http://schemas.openxmlformats.org/presentationml/2006/main">
-  <p:cSld>
-    <p:spTree>
-      <p:nvGrpSpPr>
-        <p:cNvPr id="1" name=""/>
-        <p:cNvGrpSpPr/>
-        <p:nvPr/>
-      </p:nvGrpSpPr>
-      <p:grpSpPr>
-        <a:xfrm>
-          <a:off x="0" y="0"/>
-          <a:ext cx="0" cy="0"/>
-          <a:chOff x="0" y="0"/>
-          <a:chExt cx="0" cy="0"/>
-        </a:xfrm>
-      </p:grpSpPr>
-      <p:sp>
-        <p:nvSpPr>
-          <p:cNvPr id="5" name="Add-in_Banner">
-            <a:extLst>
-              <a:ext uri="{FF2B5EF4-FFF2-40B4-BE49-F238E27FC236}">
-                <a16:creationId xmlns:a16="http://schemas.microsoft.com/office/drawing/2014/main" id="{3A30FB22-F368-4CB2-D391-EC21745707D5}"/>
-              </a:ext>
-            </a:extLst>
-          </p:cNvPr>
-          <p:cNvSpPr txBox="1">
-            <a:spLocks/>
-          </p:cNvSpPr>
-          <p:nvPr/>
-        </p:nvSpPr>
-        <p:spPr>
-          <a:xfrm>
-            <a:off x="0" y="351395"/>
-            <a:ext cx="12192000" cy="640515"/>
-          </a:xfrm>
-          <a:prstGeom prst="rect">
-            <a:avLst/>
-          </a:prstGeom>
-          <a:solidFill>
-            <a:srgbClr val="494748">
-              <a:alpha val="4706"/>
-            </a:srgbClr>
-          </a:solidFill>
-          <a:ln w="19050" cap="flat" cmpd="sng" algn="ctr">
-            <a:noFill/>
-            <a:prstDash val="solid"/>
-            <a:miter lim="800000"/>
-          </a:ln>
-        </p:spPr>
-        <p:style>
-          <a:lnRef idx="2">
-            <a:schemeClr val="accent1">
-              <a:shade val="50000"/>
-            </a:schemeClr>
-          </a:lnRef>
-          <a:fillRef idx="1">
-            <a:schemeClr val="accent1"/>
-          </a:fillRef>
-          <a:effectRef idx="0">
-            <a:schemeClr val="accent1"/>
-          </a:effectRef>
-          <a:fontRef idx="minor">
-            <a:schemeClr val="lt1"/>
-          </a:fontRef>
-        </p:style>
-        <p:txBody>
-          <a:bodyPr rot="0" spcFirstLastPara="0" vert="horz" wrap="square" lIns="1332000" tIns="180000" rIns="216000" bIns="180000" numCol="1" spcCol="0" rtlCol="0" fromWordArt="0" anchor="ctr" anchorCtr="0" forceAA="0" compatLnSpc="1">
-            <a:prstTxWarp prst="textNoShape">
-              <a:avLst/>
-            </a:prstTxWarp>
-            <a:spAutoFit/>
-          </a:bodyPr>
-          <a:lstStyle>
-            <a:defPPr>
-              <a:defRPr lang="es-ES"/>
-            </a:defPPr>
-            <a:lvl1pPr algn="l" defTabSz="914400" rtl="0" eaLnBrk="1" latinLnBrk="0" hangingPunct="1">
-              <a:lnSpc>
-                <a:spcPct val="90000"/>
-              </a:lnSpc>
-              <a:spcBef>
-                <a:spcPct val="0"/>
-              </a:spcBef>
-              <a:buNone/>
-              <a:defRPr lang="es-ES" sz="3600" i="1" kern="1200" cap="all" baseline="0">
-                <a:solidFill>
-                  <a:schemeClr val="lt1"/>
-                </a:solidFill>
-                <a:latin typeface="+mn-lt"/>
-                <a:ea typeface="+mn-ea"/>
-                <a:cs typeface="+mn-cs"/>
-              </a:defRPr>
-            </a:lvl1pPr>
-            <a:lvl2pPr>
-              <a:defRPr>
-                <a:solidFill>
-                  <a:schemeClr val="lt1"/>
-                </a:solidFill>
-                <a:latin typeface="+mn-lt"/>
-                <a:ea typeface="+mn-ea"/>
-                <a:cs typeface="+mn-cs"/>
-              </a:defRPr>
-            </a:lvl2pPr>
-            <a:lvl3pPr>
-              <a:defRPr>
-                <a:solidFill>
-                  <a:schemeClr val="lt1"/>
-                </a:solidFill>
-                <a:latin typeface="+mn-lt"/>
-                <a:ea typeface="+mn-ea"/>
-                <a:cs typeface="+mn-cs"/>
-              </a:defRPr>
-            </a:lvl3pPr>
-            <a:lvl4pPr>
-              <a:defRPr>
-                <a:solidFill>
-                  <a:schemeClr val="lt1"/>
-                </a:solidFill>
-                <a:latin typeface="+mn-lt"/>
-                <a:ea typeface="+mn-ea"/>
-                <a:cs typeface="+mn-cs"/>
-              </a:defRPr>
-            </a:lvl4pPr>
-            <a:lvl5pPr>
-              <a:defRPr>
-                <a:solidFill>
-                  <a:schemeClr val="lt1"/>
-                </a:solidFill>
-                <a:latin typeface="+mn-lt"/>
-                <a:ea typeface="+mn-ea"/>
-                <a:cs typeface="+mn-cs"/>
-              </a:defRPr>
-            </a:lvl5pPr>
-            <a:lvl6pPr>
-              <a:defRPr>
-                <a:solidFill>
-                  <a:schemeClr val="lt1"/>
-                </a:solidFill>
-                <a:latin typeface="+mn-lt"/>
-                <a:ea typeface="+mn-ea"/>
-                <a:cs typeface="+mn-cs"/>
-              </a:defRPr>
-            </a:lvl6pPr>
-            <a:lvl7pPr>
-              <a:defRPr>
-                <a:solidFill>
-                  <a:schemeClr val="lt1"/>
-                </a:solidFill>
-                <a:latin typeface="+mn-lt"/>
-                <a:ea typeface="+mn-ea"/>
-                <a:cs typeface="+mn-cs"/>
-              </a:defRPr>
-            </a:lvl7pPr>
-            <a:lvl8pPr>
-              <a:defRPr>
-                <a:solidFill>
-                  <a:schemeClr val="lt1"/>
-                </a:solidFill>
-                <a:latin typeface="+mn-lt"/>
-                <a:ea typeface="+mn-ea"/>
-                <a:cs typeface="+mn-cs"/>
-              </a:defRPr>
-            </a:lvl8pPr>
-            <a:lvl9pPr>
-              <a:defRPr>
-                <a:solidFill>
-                  <a:schemeClr val="lt1"/>
-                </a:solidFill>
-                <a:latin typeface="+mn-lt"/>
-                <a:ea typeface="+mn-ea"/>
-                <a:cs typeface="+mn-cs"/>
-              </a:defRPr>
-            </a:lvl9pPr>
-          </a:lstStyle>
-          <a:p>
-            <a:r>
-              <a:rPr lang="en-GB" sz="1800">
-                <a:solidFill>
-                  <a:srgbClr val="000000"/>
-                </a:solidFill>
-                <a:latin typeface="Segoe UI Light" panose="020B0502040204020203" pitchFamily="34" charset="0"/>
-                <a:ea typeface="Calibri" panose="020F0502020204030204" pitchFamily="34" charset="0"/>
-                <a:cs typeface="Segoe UI Light" panose="020B0502040204020203" pitchFamily="34" charset="0"/>
-              </a:rPr>
-              <a:t>Microsoft Power BI</a:t>
-            </a:r>
-            <a:endParaRPr lang="en-IE" sz="1200" dirty="0">
-              <a:latin typeface="Segoe UI Light" panose="020B0502040204020203" pitchFamily="34" charset="0"/>
-              <a:ea typeface="Calibri" panose="020F0502020204030204" pitchFamily="34" charset="0"/>
-              <a:cs typeface="Segoe UI Light" panose="020B0502040204020203" pitchFamily="34" charset="0"/>
-            </a:endParaRPr>
-          </a:p>
-        </p:txBody>
-      </p:sp>
-      <p:pic>
-        <p:nvPicPr>
-          <p:cNvPr id="6" name="Add-in_Icon" descr="Icono de Microsoft Power BI.">
-            <a:extLst>
-              <a:ext uri="{FF2B5EF4-FFF2-40B4-BE49-F238E27FC236}">
-                <a16:creationId xmlns:a16="http://schemas.microsoft.com/office/drawing/2014/main" id="{925F527C-0053-D686-AAEA-6F2B90C47242}"/>
-              </a:ext>
-            </a:extLst>
-          </p:cNvPr>
-          <p:cNvPicPr/>
-          <p:nvPr/>
-        </p:nvPicPr>
-        <p:blipFill>
-          <a:blip r:embed="rId2"/>
-          <a:stretch>
-            <a:fillRect/>
-          </a:stretch>
-        </p:blipFill>
-        <p:spPr bwMode="auto">
-          <a:xfrm>
-            <a:off x="914400" y="530365"/>
-            <a:ext cx="291465" cy="291465"/>
-          </a:xfrm>
-          <a:prstGeom prst="rect">
-            <a:avLst/>
-          </a:prstGeom>
-          <a:noFill/>
-        </p:spPr>
-      </p:pic>
-      <mc:AlternateContent xmlns:mc="http://schemas.openxmlformats.org/markup-compatibility/2006">
-        <mc:Choice xmlns:we="http://schemas.microsoft.com/office/webextensions/webextension/2010/11" xmlns:pca="http://schemas.microsoft.com/office/powerpoint/2013/contentapp" Requires="we pca">
-          <p:graphicFrame>
-            <p:nvGraphicFramePr>
-              <p:cNvPr id="7" name="Add-in" descr="Contenido de complemento para Microsoft Power BI.">
-                <a:extLst>
-                  <a:ext uri="{FF2B5EF4-FFF2-40B4-BE49-F238E27FC236}">
-                    <a16:creationId xmlns:a16="http://schemas.microsoft.com/office/drawing/2014/main" id="{7451A9BC-A222-E697-B28C-B1BF2517B1F6}"/>
-                  </a:ext>
-                </a:extLst>
-              </p:cNvPr>
-              <p:cNvGraphicFramePr>
-                <a:graphicFrameLocks noGrp="1"/>
-              </p:cNvGraphicFramePr>
-              <p:nvPr/>
-            </p:nvGraphicFramePr>
-            <p:xfrm>
-              <a:off x="721012" y="1170879"/>
-              <a:ext cx="10749976" cy="5335725"/>
-            </p:xfrm>
-            <a:graphic>
-              <a:graphicData uri="http://schemas.microsoft.com/office/webextensions/webextension/2010/11">
-                <we:webextensionref xmlns:we="http://schemas.microsoft.com/office/webextensions/webextension/2010/11" xmlns:r="http://schemas.openxmlformats.org/officeDocument/2006/relationships" r:id="rId3"/>
-              </a:graphicData>
-            </a:graphic>
-          </p:graphicFrame>
-        </mc:Choice>
-        <mc:Fallback>
-          <p:pic>
-            <p:nvPicPr>
-              <p:cNvPr id="7" name="Add-in" descr="Contenido de complemento para Microsoft Power BI.">
-                <a:extLst>
-                  <a:ext uri="{FF2B5EF4-FFF2-40B4-BE49-F238E27FC236}">
-                    <a16:creationId xmlns:a16="http://schemas.microsoft.com/office/drawing/2014/main" id="{7451A9BC-A222-E697-B28C-B1BF2517B1F6}"/>
-                  </a:ext>
-                </a:extLst>
-              </p:cNvPr>
-              <p:cNvPicPr>
-                <a:picLocks noGrp="1" noRot="1" noChangeAspect="1" noMove="1" noResize="1" noEditPoints="1" noAdjustHandles="1" noChangeArrowheads="1" noChangeShapeType="1"/>
-              </p:cNvPicPr>
-              <p:nvPr/>
-            </p:nvPicPr>
-            <p:blipFill>
-              <a:blip r:embed="rId4"/>
-              <a:stretch>
-                <a:fillRect/>
-              </a:stretch>
-            </p:blipFill>
-            <p:spPr>
-              <a:xfrm>
-                <a:off x="721012" y="1170879"/>
-                <a:ext cx="10749976" cy="5335725"/>
-              </a:xfrm>
-              <a:prstGeom prst="rect">
-                <a:avLst/>
-              </a:prstGeom>
-            </p:spPr>
-          </p:pic>
-        </mc:Fallback>
-      </mc:AlternateContent>
-    </p:spTree>
-    <p:extLst>
-      <p:ext uri="{BB962C8B-B14F-4D97-AF65-F5344CB8AC3E}">
-        <p14:creationId xmlns:p14="http://schemas.microsoft.com/office/powerpoint/2010/main" val="4112581839"/>
-      </p:ext>
-    </p:extLst>
-  </p:cSld>
-  <p:clrMapOvr>
-    <a:masterClrMapping/>
-  </p:clrMapOvr>
-</p:sld>
-</file>
-
-<file path=ppt/slides/slide11.xml><?xml version="1.0" encoding="utf-8"?>
-<p:sld xmlns:a="http://schemas.openxmlformats.org/drawingml/2006/main" xmlns:r="http://schemas.openxmlformats.org/officeDocument/2006/relationships" xmlns:p="http://schemas.openxmlformats.org/presentationml/2006/main">
+<p:sld xmlns:a="http://schemas.openxmlformats.org/drawingml/2006/main" xmlns:r="http://schemas.openxmlformats.org/officeDocument/2006/relationships" xmlns:p="http://schemas.openxmlformats.org/presentationml/2006/main" show="0">
   <p:cSld>
     <p:spTree>
       <p:nvGrpSpPr>
@@ -10152,7 +9726,7 @@
 </p:sld>
 </file>
 
-<file path=ppt/slides/slide12.xml><?xml version="1.0" encoding="utf-8"?>
+<file path=ppt/slides/slide11.xml><?xml version="1.0" encoding="utf-8"?>
 <p:sld xmlns:a="http://schemas.openxmlformats.org/drawingml/2006/main" xmlns:r="http://schemas.openxmlformats.org/officeDocument/2006/relationships" xmlns:p="http://schemas.openxmlformats.org/presentationml/2006/main">
   <p:cSld>
     <p:spTree>
@@ -10219,593 +9793,6 @@
           </a:p>
         </p:txBody>
       </p:sp>
-      <p:graphicFrame>
-        <p:nvGraphicFramePr>
-          <p:cNvPr id="3" name="Marcador de posición de la tabla 2">
-            <a:extLst>
-              <a:ext uri="{FF2B5EF4-FFF2-40B4-BE49-F238E27FC236}">
-                <a16:creationId xmlns:a16="http://schemas.microsoft.com/office/drawing/2014/main" id="{F01CF5D3-D3B1-1944-CFDF-D8EE11DE42AA}"/>
-              </a:ext>
-            </a:extLst>
-          </p:cNvPr>
-          <p:cNvGraphicFramePr>
-            <a:graphicFrameLocks noGrp="1"/>
-          </p:cNvGraphicFramePr>
-          <p:nvPr>
-            <p:ph type="tbl" sz="quarter" idx="13"/>
-            <p:extLst>
-              <p:ext uri="{D42A27DB-BD31-4B8C-83A1-F6EECF244321}">
-                <p14:modId xmlns:p14="http://schemas.microsoft.com/office/powerpoint/2010/main" val="1132532233"/>
-              </p:ext>
-            </p:extLst>
-          </p:nvPr>
-        </p:nvGraphicFramePr>
-        <p:xfrm>
-          <a:off x="4108450" y="2136775"/>
-          <a:ext cx="7059592" cy="4260565"/>
-        </p:xfrm>
-        <a:graphic>
-          <a:graphicData uri="http://schemas.openxmlformats.org/drawingml/2006/table">
-            <a:tbl>
-              <a:tblPr firstRow="1" bandRow="1">
-                <a:tableStyleId>{9DCAF9ED-07DC-4A11-8D7F-57B35C25682E}</a:tableStyleId>
-              </a:tblPr>
-              <a:tblGrid>
-                <a:gridCol w="1764898">
-                  <a:extLst>
-                    <a:ext uri="{9D8B030D-6E8A-4147-A177-3AD203B41FA5}">
-                      <a16:colId xmlns:a16="http://schemas.microsoft.com/office/drawing/2014/main" val="127040821"/>
-                    </a:ext>
-                  </a:extLst>
-                </a:gridCol>
-                <a:gridCol w="1764898">
-                  <a:extLst>
-                    <a:ext uri="{9D8B030D-6E8A-4147-A177-3AD203B41FA5}">
-                      <a16:colId xmlns:a16="http://schemas.microsoft.com/office/drawing/2014/main" val="149845700"/>
-                    </a:ext>
-                  </a:extLst>
-                </a:gridCol>
-                <a:gridCol w="1764898">
-                  <a:extLst>
-                    <a:ext uri="{9D8B030D-6E8A-4147-A177-3AD203B41FA5}">
-                      <a16:colId xmlns:a16="http://schemas.microsoft.com/office/drawing/2014/main" val="3119692462"/>
-                    </a:ext>
-                  </a:extLst>
-                </a:gridCol>
-                <a:gridCol w="1764898">
-                  <a:extLst>
-                    <a:ext uri="{9D8B030D-6E8A-4147-A177-3AD203B41FA5}">
-                      <a16:colId xmlns:a16="http://schemas.microsoft.com/office/drawing/2014/main" val="3472639139"/>
-                    </a:ext>
-                  </a:extLst>
-                </a:gridCol>
-              </a:tblGrid>
-              <a:tr h="511525">
-                <a:tc>
-                  <a:txBody>
-                    <a:bodyPr/>
-                    <a:lstStyle>
-                      <a:defPPr>
-                        <a:defRPr lang="es-ES"/>
-                      </a:defPPr>
-                    </a:lstStyle>
-                    <a:p>
-                      <a:pPr algn="ctr" rtl="0"/>
-                      <a:r>
-                        <a:rPr lang="es-ES" b="0" i="0" dirty="0">
-                          <a:latin typeface="+mn-lt"/>
-                        </a:rPr>
-                        <a:t>Métrico</a:t>
-                      </a:r>
-                    </a:p>
-                  </a:txBody>
-                  <a:tcPr anchor="ctr"/>
-                </a:tc>
-                <a:tc>
-                  <a:txBody>
-                    <a:bodyPr/>
-                    <a:lstStyle>
-                      <a:defPPr>
-                        <a:defRPr lang="es-ES"/>
-                      </a:defPPr>
-                    </a:lstStyle>
-                    <a:p>
-                      <a:pPr algn="ctr" rtl="0"/>
-                      <a:r>
-                        <a:rPr lang="es-ES" b="0" i="0">
-                          <a:latin typeface="+mn-lt"/>
-                        </a:rPr>
-                        <a:t>Medida</a:t>
-                      </a:r>
-                    </a:p>
-                  </a:txBody>
-                  <a:tcPr anchor="ctr"/>
-                </a:tc>
-                <a:tc>
-                  <a:txBody>
-                    <a:bodyPr/>
-                    <a:lstStyle>
-                      <a:defPPr>
-                        <a:defRPr lang="es-ES"/>
-                      </a:defPPr>
-                    </a:lstStyle>
-                    <a:p>
-                      <a:pPr algn="ctr" rtl="0"/>
-                      <a:r>
-                        <a:rPr lang="es-ES" b="0" i="0">
-                          <a:latin typeface="+mn-lt"/>
-                        </a:rPr>
-                        <a:t>Objetivo</a:t>
-                      </a:r>
-                    </a:p>
-                  </a:txBody>
-                  <a:tcPr anchor="ctr"/>
-                </a:tc>
-                <a:tc>
-                  <a:txBody>
-                    <a:bodyPr/>
-                    <a:lstStyle>
-                      <a:defPPr>
-                        <a:defRPr lang="es-ES"/>
-                      </a:defPPr>
-                    </a:lstStyle>
-                    <a:p>
-                      <a:pPr algn="ctr" rtl="0"/>
-                      <a:r>
-                        <a:rPr lang="es-ES" b="0" i="0">
-                          <a:latin typeface="+mn-lt"/>
-                        </a:rPr>
-                        <a:t>Real</a:t>
-                      </a:r>
-                    </a:p>
-                  </a:txBody>
-                  <a:tcPr anchor="ctr"/>
-                </a:tc>
-                <a:extLst>
-                  <a:ext uri="{0D108BD9-81ED-4DB2-BD59-A6C34878D82A}">
-                    <a16:rowId xmlns:a16="http://schemas.microsoft.com/office/drawing/2014/main" val="3298013591"/>
-                  </a:ext>
-                </a:extLst>
-              </a:tr>
-              <a:tr h="582969">
-                <a:tc>
-                  <a:txBody>
-                    <a:bodyPr/>
-                    <a:lstStyle>
-                      <a:defPPr>
-                        <a:defRPr lang="es-ES"/>
-                      </a:defPPr>
-                    </a:lstStyle>
-                    <a:p>
-                      <a:pPr algn="ctr" rtl="0"/>
-                      <a:r>
-                        <a:rPr lang="es-ES" b="0" i="0">
-                          <a:latin typeface="+mn-lt"/>
-                        </a:rPr>
-                        <a:t>Asistencia del público</a:t>
-                      </a:r>
-                    </a:p>
-                  </a:txBody>
-                  <a:tcPr anchor="ctr"/>
-                </a:tc>
-                <a:tc>
-                  <a:txBody>
-                    <a:bodyPr/>
-                    <a:lstStyle>
-                      <a:defPPr>
-                        <a:defRPr lang="es-ES"/>
-                      </a:defPPr>
-                    </a:lstStyle>
-                    <a:p>
-                      <a:pPr algn="ctr" rtl="0"/>
-                      <a:r>
-                        <a:rPr lang="es-ES" b="0" i="0">
-                          <a:latin typeface="+mn-lt"/>
-                        </a:rPr>
-                        <a:t>N.º de asistentes</a:t>
-                      </a:r>
-                    </a:p>
-                  </a:txBody>
-                  <a:tcPr anchor="ctr"/>
-                </a:tc>
-                <a:tc>
-                  <a:txBody>
-                    <a:bodyPr/>
-                    <a:lstStyle>
-                      <a:defPPr>
-                        <a:defRPr lang="es-ES"/>
-                      </a:defPPr>
-                    </a:lstStyle>
-                    <a:p>
-                      <a:pPr algn="ctr" rtl="0"/>
-                      <a:r>
-                        <a:rPr lang="es-ES" b="0" i="0">
-                          <a:latin typeface="+mn-lt"/>
-                        </a:rPr>
-                        <a:t>150</a:t>
-                      </a:r>
-                    </a:p>
-                  </a:txBody>
-                  <a:tcPr anchor="ctr"/>
-                </a:tc>
-                <a:tc>
-                  <a:txBody>
-                    <a:bodyPr/>
-                    <a:lstStyle>
-                      <a:defPPr>
-                        <a:defRPr lang="es-ES"/>
-                      </a:defPPr>
-                    </a:lstStyle>
-                    <a:p>
-                      <a:pPr algn="ctr" rtl="0"/>
-                      <a:r>
-                        <a:rPr lang="es-ES" b="0" i="0">
-                          <a:latin typeface="+mn-lt"/>
-                        </a:rPr>
-                        <a:t>120</a:t>
-                      </a:r>
-                    </a:p>
-                  </a:txBody>
-                  <a:tcPr anchor="ctr"/>
-                </a:tc>
-                <a:extLst>
-                  <a:ext uri="{0D108BD9-81ED-4DB2-BD59-A6C34878D82A}">
-                    <a16:rowId xmlns:a16="http://schemas.microsoft.com/office/drawing/2014/main" val="3873867931"/>
-                  </a:ext>
-                </a:extLst>
-              </a:tr>
-              <a:tr h="582969">
-                <a:tc>
-                  <a:txBody>
-                    <a:bodyPr/>
-                    <a:lstStyle>
-                      <a:defPPr>
-                        <a:defRPr lang="es-ES"/>
-                      </a:defPPr>
-                    </a:lstStyle>
-                    <a:p>
-                      <a:pPr algn="ctr" rtl="0"/>
-                      <a:r>
-                        <a:rPr lang="es-ES" b="0" i="0">
-                          <a:latin typeface="+mn-lt"/>
-                        </a:rPr>
-                        <a:t>Duración de la interacción</a:t>
-                      </a:r>
-                    </a:p>
-                  </a:txBody>
-                  <a:tcPr anchor="ctr"/>
-                </a:tc>
-                <a:tc>
-                  <a:txBody>
-                    <a:bodyPr/>
-                    <a:lstStyle>
-                      <a:defPPr>
-                        <a:defRPr lang="es-ES"/>
-                      </a:defPPr>
-                    </a:lstStyle>
-                    <a:p>
-                      <a:pPr algn="ctr" rtl="0"/>
-                      <a:r>
-                        <a:rPr lang="es-ES" b="0" i="0" dirty="0">
-                          <a:latin typeface="+mn-lt"/>
-                        </a:rPr>
-                        <a:t>Minutos</a:t>
-                      </a:r>
-                    </a:p>
-                  </a:txBody>
-                  <a:tcPr anchor="ctr"/>
-                </a:tc>
-                <a:tc>
-                  <a:txBody>
-                    <a:bodyPr/>
-                    <a:lstStyle>
-                      <a:defPPr>
-                        <a:defRPr lang="es-ES"/>
-                      </a:defPPr>
-                    </a:lstStyle>
-                    <a:p>
-                      <a:pPr algn="ctr" rtl="0"/>
-                      <a:r>
-                        <a:rPr lang="es-ES" b="0" i="0">
-                          <a:latin typeface="+mn-lt"/>
-                        </a:rPr>
-                        <a:t>60</a:t>
-                      </a:r>
-                    </a:p>
-                  </a:txBody>
-                  <a:tcPr anchor="ctr"/>
-                </a:tc>
-                <a:tc>
-                  <a:txBody>
-                    <a:bodyPr/>
-                    <a:lstStyle>
-                      <a:defPPr>
-                        <a:defRPr lang="es-ES"/>
-                      </a:defPPr>
-                    </a:lstStyle>
-                    <a:p>
-                      <a:pPr algn="ctr" rtl="0"/>
-                      <a:r>
-                        <a:rPr lang="es-ES" b="0" i="0">
-                          <a:latin typeface="+mn-lt"/>
-                        </a:rPr>
-                        <a:t>75</a:t>
-                      </a:r>
-                    </a:p>
-                  </a:txBody>
-                  <a:tcPr anchor="ctr"/>
-                </a:tc>
-                <a:extLst>
-                  <a:ext uri="{0D108BD9-81ED-4DB2-BD59-A6C34878D82A}">
-                    <a16:rowId xmlns:a16="http://schemas.microsoft.com/office/drawing/2014/main" val="85209771"/>
-                  </a:ext>
-                </a:extLst>
-              </a:tr>
-              <a:tr h="582969">
-                <a:tc>
-                  <a:txBody>
-                    <a:bodyPr/>
-                    <a:lstStyle>
-                      <a:defPPr>
-                        <a:defRPr lang="es-ES"/>
-                      </a:defPPr>
-                    </a:lstStyle>
-                    <a:p>
-                      <a:pPr algn="ctr" rtl="0"/>
-                      <a:r>
-                        <a:rPr lang="es-ES" b="0" i="0" dirty="0">
-                          <a:latin typeface="+mn-lt"/>
-                        </a:rPr>
-                        <a:t>Interacción de preguntas y respuestas</a:t>
-                      </a:r>
-                    </a:p>
-                  </a:txBody>
-                  <a:tcPr anchor="ctr"/>
-                </a:tc>
-                <a:tc>
-                  <a:txBody>
-                    <a:bodyPr/>
-                    <a:lstStyle>
-                      <a:defPPr>
-                        <a:defRPr lang="es-ES"/>
-                      </a:defPPr>
-                    </a:lstStyle>
-                    <a:p>
-                      <a:pPr algn="ctr" rtl="0"/>
-                      <a:r>
-                        <a:rPr lang="es-ES" b="0" i="0">
-                          <a:latin typeface="+mn-lt"/>
-                        </a:rPr>
-                        <a:t>N.º de preguntas</a:t>
-                      </a:r>
-                    </a:p>
-                  </a:txBody>
-                  <a:tcPr anchor="ctr"/>
-                </a:tc>
-                <a:tc>
-                  <a:txBody>
-                    <a:bodyPr/>
-                    <a:lstStyle>
-                      <a:defPPr>
-                        <a:defRPr lang="es-ES"/>
-                      </a:defPPr>
-                    </a:lstStyle>
-                    <a:p>
-                      <a:pPr algn="ctr" rtl="0"/>
-                      <a:r>
-                        <a:rPr lang="es-ES" b="0" i="0" dirty="0">
-                          <a:latin typeface="+mn-lt"/>
-                        </a:rPr>
-                        <a:t>10</a:t>
-                      </a:r>
-                    </a:p>
-                  </a:txBody>
-                  <a:tcPr anchor="ctr"/>
-                </a:tc>
-                <a:tc>
-                  <a:txBody>
-                    <a:bodyPr/>
-                    <a:lstStyle>
-                      <a:defPPr>
-                        <a:defRPr lang="es-ES"/>
-                      </a:defPPr>
-                    </a:lstStyle>
-                    <a:p>
-                      <a:pPr algn="ctr" rtl="0"/>
-                      <a:r>
-                        <a:rPr lang="es-ES" b="0" i="0">
-                          <a:latin typeface="+mn-lt"/>
-                        </a:rPr>
-                        <a:t>15</a:t>
-                      </a:r>
-                    </a:p>
-                  </a:txBody>
-                  <a:tcPr anchor="ctr"/>
-                </a:tc>
-                <a:extLst>
-                  <a:ext uri="{0D108BD9-81ED-4DB2-BD59-A6C34878D82A}">
-                    <a16:rowId xmlns:a16="http://schemas.microsoft.com/office/drawing/2014/main" val="4061031278"/>
-                  </a:ext>
-                </a:extLst>
-              </a:tr>
-              <a:tr h="582969">
-                <a:tc>
-                  <a:txBody>
-                    <a:bodyPr/>
-                    <a:lstStyle>
-                      <a:defPPr>
-                        <a:defRPr lang="es-ES"/>
-                      </a:defPPr>
-                    </a:lstStyle>
-                    <a:p>
-                      <a:pPr algn="ctr" rtl="0"/>
-                      <a:r>
-                        <a:rPr lang="es-ES" b="0" i="0">
-                          <a:latin typeface="+mn-lt"/>
-                        </a:rPr>
-                        <a:t>Comentarios positivos</a:t>
-                      </a:r>
-                    </a:p>
-                  </a:txBody>
-                  <a:tcPr anchor="ctr"/>
-                </a:tc>
-                <a:tc>
-                  <a:txBody>
-                    <a:bodyPr/>
-                    <a:lstStyle>
-                      <a:defPPr>
-                        <a:defRPr lang="es-ES"/>
-                      </a:defPPr>
-                    </a:lstStyle>
-                    <a:p>
-                      <a:pPr algn="ctr" rtl="0"/>
-                      <a:r>
-                        <a:rPr lang="es-ES" b="0" i="0">
-                          <a:latin typeface="+mn-lt"/>
-                        </a:rPr>
-                        <a:t>Porcentaje (%)</a:t>
-                      </a:r>
-                    </a:p>
-                  </a:txBody>
-                  <a:tcPr anchor="ctr"/>
-                </a:tc>
-                <a:tc>
-                  <a:txBody>
-                    <a:bodyPr/>
-                    <a:lstStyle>
-                      <a:defPPr>
-                        <a:defRPr lang="es-ES"/>
-                      </a:defPPr>
-                    </a:lstStyle>
-                    <a:p>
-                      <a:pPr algn="ctr" rtl="0"/>
-                      <a:r>
-                        <a:rPr lang="es-ES" b="0" i="0">
-                          <a:latin typeface="+mn-lt"/>
-                        </a:rPr>
-                        <a:t>90</a:t>
-                      </a:r>
-                    </a:p>
-                  </a:txBody>
-                  <a:tcPr anchor="ctr"/>
-                </a:tc>
-                <a:tc>
-                  <a:txBody>
-                    <a:bodyPr/>
-                    <a:lstStyle>
-                      <a:defPPr>
-                        <a:defRPr lang="es-ES"/>
-                      </a:defPPr>
-                    </a:lstStyle>
-                    <a:p>
-                      <a:pPr algn="ctr" rtl="0"/>
-                      <a:r>
-                        <a:rPr lang="es-ES" b="0" i="0" dirty="0">
-                          <a:latin typeface="+mn-lt"/>
-                        </a:rPr>
-                        <a:t>95</a:t>
-                      </a:r>
-                    </a:p>
-                  </a:txBody>
-                  <a:tcPr anchor="ctr"/>
-                </a:tc>
-                <a:extLst>
-                  <a:ext uri="{0D108BD9-81ED-4DB2-BD59-A6C34878D82A}">
-                    <a16:rowId xmlns:a16="http://schemas.microsoft.com/office/drawing/2014/main" val="3591840781"/>
-                  </a:ext>
-                </a:extLst>
-              </a:tr>
-              <a:tr h="832813">
-                <a:tc>
-                  <a:txBody>
-                    <a:bodyPr/>
-                    <a:lstStyle>
-                      <a:defPPr>
-                        <a:defRPr lang="es-ES"/>
-                      </a:defPPr>
-                    </a:lstStyle>
-                    <a:p>
-                      <a:pPr algn="ctr" rtl="0"/>
-                      <a:r>
-                        <a:rPr lang="es-ES" b="0" i="0">
-                          <a:latin typeface="+mn-lt"/>
-                        </a:rPr>
-                        <a:t>Tasa de retención de información</a:t>
-                      </a:r>
-                    </a:p>
-                  </a:txBody>
-                  <a:tcPr anchor="ctr"/>
-                </a:tc>
-                <a:tc>
-                  <a:txBody>
-                    <a:bodyPr/>
-                    <a:lstStyle>
-                      <a:defPPr>
-                        <a:defRPr lang="es-ES"/>
-                      </a:defPPr>
-                    </a:lstStyle>
-                    <a:p>
-                      <a:pPr algn="ctr" rtl="0"/>
-                      <a:r>
-                        <a:rPr lang="es-ES" b="0" i="0">
-                          <a:latin typeface="+mn-lt"/>
-                        </a:rPr>
-                        <a:t>Porcentaje (%)</a:t>
-                      </a:r>
-                    </a:p>
-                  </a:txBody>
-                  <a:tcPr anchor="ctr"/>
-                </a:tc>
-                <a:tc>
-                  <a:txBody>
-                    <a:bodyPr/>
-                    <a:lstStyle>
-                      <a:defPPr>
-                        <a:defRPr lang="es-ES"/>
-                      </a:defPPr>
-                    </a:lstStyle>
-                    <a:p>
-                      <a:pPr algn="ctr" rtl="0"/>
-                      <a:r>
-                        <a:rPr lang="es-ES" b="0" i="0">
-                          <a:latin typeface="+mn-lt"/>
-                        </a:rPr>
-                        <a:t>80</a:t>
-                      </a:r>
-                    </a:p>
-                  </a:txBody>
-                  <a:tcPr anchor="ctr"/>
-                </a:tc>
-                <a:tc>
-                  <a:txBody>
-                    <a:bodyPr/>
-                    <a:lstStyle>
-                      <a:defPPr>
-                        <a:defRPr lang="es-ES"/>
-                      </a:defPPr>
-                    </a:lstStyle>
-                    <a:p>
-                      <a:pPr algn="ctr" rtl="0"/>
-                      <a:r>
-                        <a:rPr lang="es-ES" b="0" i="0" dirty="0">
-                          <a:latin typeface="+mn-lt"/>
-                        </a:rPr>
-                        <a:t>85</a:t>
-                      </a:r>
-                    </a:p>
-                  </a:txBody>
-                  <a:tcPr anchor="ctr"/>
-                </a:tc>
-                <a:extLst>
-                  <a:ext uri="{0D108BD9-81ED-4DB2-BD59-A6C34878D82A}">
-                    <a16:rowId xmlns:a16="http://schemas.microsoft.com/office/drawing/2014/main" val="335389741"/>
-                  </a:ext>
-                </a:extLst>
-              </a:tr>
-            </a:tbl>
-          </a:graphicData>
-        </a:graphic>
-      </p:graphicFrame>
       <p:sp>
         <p:nvSpPr>
           <p:cNvPr id="9" name="Content Placeholder 2">
@@ -10824,64 +9811,66 @@
         </p:nvSpPr>
         <p:spPr>
           <a:xfrm>
-            <a:off x="457200" y="1600200"/>
+            <a:off x="1490472" y="1527048"/>
             <a:ext cx="8229600" cy="4525963"/>
           </a:xfrm>
         </p:spPr>
         <p:txBody>
-          <a:bodyPr/>
+          <a:bodyPr>
+            <a:normAutofit fontScale="92500" lnSpcReduction="10000"/>
+          </a:bodyPr>
           <a:lstStyle/>
           <a:p>
             <a:r>
-              <a:rPr dirty="0"/>
+              <a:rPr sz="2400" dirty="0"/>
               <a:t>Inputs:</a:t>
             </a:r>
           </a:p>
           <a:p>
             <a:r>
-              <a:rPr dirty="0"/>
+              <a:rPr sz="2400" dirty="0"/>
               <a:t>• Real-time telemetry</a:t>
             </a:r>
           </a:p>
           <a:p>
             <a:r>
-              <a:rPr dirty="0"/>
+              <a:rPr sz="2400" dirty="0"/>
               <a:t>• Historical datasets</a:t>
             </a:r>
           </a:p>
           <a:p>
-            <a:endParaRPr dirty="0"/>
-          </a:p>
-          <a:p>
-            <a:r>
-              <a:rPr dirty="0"/>
+            <a:endParaRPr sz="2400" dirty="0"/>
+          </a:p>
+          <a:p>
+            <a:r>
+              <a:rPr sz="2400" dirty="0"/>
               <a:t>Outputs:</a:t>
             </a:r>
           </a:p>
           <a:p>
             <a:r>
-              <a:rPr dirty="0"/>
+              <a:rPr sz="2400" dirty="0"/>
               <a:t>• System state</a:t>
             </a:r>
           </a:p>
           <a:p>
             <a:r>
-              <a:rPr dirty="0"/>
+              <a:rPr sz="2400" dirty="0"/>
               <a:t>• Performance indicators</a:t>
             </a:r>
           </a:p>
           <a:p>
             <a:r>
-              <a:rPr dirty="0"/>
+              <a:rPr sz="2400" dirty="0"/>
               <a:t>• Diagnostic insights</a:t>
             </a:r>
           </a:p>
           <a:p>
-            <a:endParaRPr dirty="0"/>
-          </a:p>
-          <a:p>
-            <a:r>
-              <a:rPr dirty="0"/>
+            <a:endParaRPr sz="2400" dirty="0"/>
+          </a:p>
+          <a:p>
+            <a:r>
+              <a:rPr sz="2400" dirty="0"/>
               <a:t>Twin updated continuously.</a:t>
             </a:r>
           </a:p>
@@ -10900,7 +9889,7 @@
 </p:sld>
 </file>
 
-<file path=ppt/slides/slide13.xml><?xml version="1.0" encoding="utf-8"?>
+<file path=ppt/slides/slide12.xml><?xml version="1.0" encoding="utf-8"?>
 <p:sld xmlns:a="http://schemas.openxmlformats.org/drawingml/2006/main" xmlns:r="http://schemas.openxmlformats.org/officeDocument/2006/relationships" xmlns:p="http://schemas.openxmlformats.org/presentationml/2006/main">
   <p:cSld>
     <p:spTree>
@@ -11213,7 +10202,7 @@
 </p:sld>
 </file>
 
-<file path=ppt/slides/slide14.xml><?xml version="1.0" encoding="utf-8"?>
+<file path=ppt/slides/slide13.xml><?xml version="1.0" encoding="utf-8"?>
 <p:sld xmlns:a="http://schemas.openxmlformats.org/drawingml/2006/main" xmlns:r="http://schemas.openxmlformats.org/officeDocument/2006/relationships" xmlns:p="http://schemas.openxmlformats.org/presentationml/2006/main">
   <p:cSld>
     <p:spTree>
@@ -11282,593 +10271,6 @@
           </a:p>
         </p:txBody>
       </p:sp>
-      <p:graphicFrame>
-        <p:nvGraphicFramePr>
-          <p:cNvPr id="19" name="Marcador de posición de tabla 3">
-            <a:extLst>
-              <a:ext uri="{FF2B5EF4-FFF2-40B4-BE49-F238E27FC236}">
-                <a16:creationId xmlns:a16="http://schemas.microsoft.com/office/drawing/2014/main" id="{998759BF-36E2-2AC0-C9B8-88C6BF075154}"/>
-              </a:ext>
-            </a:extLst>
-          </p:cNvPr>
-          <p:cNvGraphicFramePr>
-            <a:graphicFrameLocks noGrp="1"/>
-          </p:cNvGraphicFramePr>
-          <p:nvPr>
-            <p:ph type="tbl" sz="quarter" idx="13"/>
-            <p:extLst>
-              <p:ext uri="{D42A27DB-BD31-4B8C-83A1-F6EECF244321}">
-                <p14:modId xmlns:p14="http://schemas.microsoft.com/office/powerpoint/2010/main" val="2440822416"/>
-              </p:ext>
-            </p:extLst>
-          </p:nvPr>
-        </p:nvGraphicFramePr>
-        <p:xfrm>
-          <a:off x="6976872" y="1220407"/>
-          <a:ext cx="6004560" cy="5486400"/>
-        </p:xfrm>
-        <a:graphic>
-          <a:graphicData uri="http://schemas.openxmlformats.org/drawingml/2006/table">
-            <a:tbl>
-              <a:tblPr firstRow="1" bandRow="1">
-                <a:tableStyleId>{9DCAF9ED-07DC-4A11-8D7F-57B35C25682E}</a:tableStyleId>
-              </a:tblPr>
-              <a:tblGrid>
-                <a:gridCol w="1501140">
-                  <a:extLst>
-                    <a:ext uri="{9D8B030D-6E8A-4147-A177-3AD203B41FA5}">
-                      <a16:colId xmlns:a16="http://schemas.microsoft.com/office/drawing/2014/main" val="2382218087"/>
-                    </a:ext>
-                  </a:extLst>
-                </a:gridCol>
-                <a:gridCol w="1501140">
-                  <a:extLst>
-                    <a:ext uri="{9D8B030D-6E8A-4147-A177-3AD203B41FA5}">
-                      <a16:colId xmlns:a16="http://schemas.microsoft.com/office/drawing/2014/main" val="3953468724"/>
-                    </a:ext>
-                  </a:extLst>
-                </a:gridCol>
-                <a:gridCol w="1501140">
-                  <a:extLst>
-                    <a:ext uri="{9D8B030D-6E8A-4147-A177-3AD203B41FA5}">
-                      <a16:colId xmlns:a16="http://schemas.microsoft.com/office/drawing/2014/main" val="4277526474"/>
-                    </a:ext>
-                  </a:extLst>
-                </a:gridCol>
-                <a:gridCol w="1501140">
-                  <a:extLst>
-                    <a:ext uri="{9D8B030D-6E8A-4147-A177-3AD203B41FA5}">
-                      <a16:colId xmlns:a16="http://schemas.microsoft.com/office/drawing/2014/main" val="2438884888"/>
-                    </a:ext>
-                  </a:extLst>
-                </a:gridCol>
-              </a:tblGrid>
-              <a:tr h="598946">
-                <a:tc>
-                  <a:txBody>
-                    <a:bodyPr/>
-                    <a:lstStyle>
-                      <a:defPPr>
-                        <a:defRPr lang="es-ES"/>
-                      </a:defPPr>
-                    </a:lstStyle>
-                    <a:p>
-                      <a:pPr algn="ctr" rtl="0"/>
-                      <a:r>
-                        <a:rPr lang="es-ES" b="0" i="0" dirty="0">
-                          <a:latin typeface="+mn-lt"/>
-                        </a:rPr>
-                        <a:t>Factor de impacto</a:t>
-                      </a:r>
-                    </a:p>
-                  </a:txBody>
-                  <a:tcPr anchor="ctr"/>
-                </a:tc>
-                <a:tc>
-                  <a:txBody>
-                    <a:bodyPr/>
-                    <a:lstStyle>
-                      <a:defPPr>
-                        <a:defRPr lang="es-ES"/>
-                      </a:defPPr>
-                    </a:lstStyle>
-                    <a:p>
-                      <a:pPr algn="ctr" rtl="0"/>
-                      <a:r>
-                        <a:rPr lang="es-ES" b="0" i="0">
-                          <a:latin typeface="+mn-lt"/>
-                        </a:rPr>
-                        <a:t>Medida</a:t>
-                      </a:r>
-                    </a:p>
-                  </a:txBody>
-                  <a:tcPr anchor="ctr"/>
-                </a:tc>
-                <a:tc>
-                  <a:txBody>
-                    <a:bodyPr/>
-                    <a:lstStyle>
-                      <a:defPPr>
-                        <a:defRPr lang="es-ES"/>
-                      </a:defPPr>
-                    </a:lstStyle>
-                    <a:p>
-                      <a:pPr algn="ctr" rtl="0"/>
-                      <a:r>
-                        <a:rPr lang="es-ES" b="0" i="0">
-                          <a:latin typeface="+mn-lt"/>
-                        </a:rPr>
-                        <a:t>Objetivo</a:t>
-                      </a:r>
-                    </a:p>
-                  </a:txBody>
-                  <a:tcPr anchor="ctr"/>
-                </a:tc>
-                <a:tc>
-                  <a:txBody>
-                    <a:bodyPr/>
-                    <a:lstStyle>
-                      <a:defPPr>
-                        <a:defRPr lang="es-ES"/>
-                      </a:defPPr>
-                    </a:lstStyle>
-                    <a:p>
-                      <a:pPr algn="ctr" rtl="0"/>
-                      <a:r>
-                        <a:rPr lang="es-ES" b="0" i="0" dirty="0">
-                          <a:latin typeface="+mn-lt"/>
-                        </a:rPr>
-                        <a:t>Logrado</a:t>
-                      </a:r>
-                    </a:p>
-                  </a:txBody>
-                  <a:tcPr anchor="ctr"/>
-                </a:tc>
-                <a:extLst>
-                  <a:ext uri="{0D108BD9-81ED-4DB2-BD59-A6C34878D82A}">
-                    <a16:rowId xmlns:a16="http://schemas.microsoft.com/office/drawing/2014/main" val="2857107962"/>
-                  </a:ext>
-                </a:extLst>
-              </a:tr>
-              <a:tr h="598946">
-                <a:tc>
-                  <a:txBody>
-                    <a:bodyPr/>
-                    <a:lstStyle>
-                      <a:defPPr>
-                        <a:defRPr lang="es-ES"/>
-                      </a:defPPr>
-                    </a:lstStyle>
-                    <a:p>
-                      <a:pPr algn="ctr" rtl="0"/>
-                      <a:r>
-                        <a:rPr lang="es-ES" b="0" i="0">
-                          <a:latin typeface="+mn-lt"/>
-                        </a:rPr>
-                        <a:t>Interacción del público</a:t>
-                      </a:r>
-                    </a:p>
-                  </a:txBody>
-                  <a:tcPr anchor="ctr"/>
-                </a:tc>
-                <a:tc>
-                  <a:txBody>
-                    <a:bodyPr/>
-                    <a:lstStyle>
-                      <a:defPPr>
-                        <a:defRPr lang="es-ES"/>
-                      </a:defPPr>
-                    </a:lstStyle>
-                    <a:p>
-                      <a:pPr algn="ctr" rtl="0"/>
-                      <a:r>
-                        <a:rPr lang="es-ES" b="0" i="0" dirty="0">
-                          <a:latin typeface="+mn-lt"/>
-                        </a:rPr>
-                        <a:t>Porcentaje (%)</a:t>
-                      </a:r>
-                    </a:p>
-                  </a:txBody>
-                  <a:tcPr anchor="ctr"/>
-                </a:tc>
-                <a:tc>
-                  <a:txBody>
-                    <a:bodyPr/>
-                    <a:lstStyle>
-                      <a:defPPr>
-                        <a:defRPr lang="es-ES"/>
-                      </a:defPPr>
-                    </a:lstStyle>
-                    <a:p>
-                      <a:pPr algn="ctr" rtl="0"/>
-                      <a:r>
-                        <a:rPr lang="es-ES" b="0" i="0">
-                          <a:latin typeface="+mn-lt"/>
-                        </a:rPr>
-                        <a:t>85</a:t>
-                      </a:r>
-                    </a:p>
-                  </a:txBody>
-                  <a:tcPr anchor="ctr"/>
-                </a:tc>
-                <a:tc>
-                  <a:txBody>
-                    <a:bodyPr/>
-                    <a:lstStyle>
-                      <a:defPPr>
-                        <a:defRPr lang="es-ES"/>
-                      </a:defPPr>
-                    </a:lstStyle>
-                    <a:p>
-                      <a:pPr algn="ctr" rtl="0"/>
-                      <a:r>
-                        <a:rPr lang="es-ES" b="0" i="0">
-                          <a:latin typeface="+mn-lt"/>
-                        </a:rPr>
-                        <a:t>88</a:t>
-                      </a:r>
-                    </a:p>
-                  </a:txBody>
-                  <a:tcPr anchor="ctr"/>
-                </a:tc>
-                <a:extLst>
-                  <a:ext uri="{0D108BD9-81ED-4DB2-BD59-A6C34878D82A}">
-                    <a16:rowId xmlns:a16="http://schemas.microsoft.com/office/drawing/2014/main" val="1671386868"/>
-                  </a:ext>
-                </a:extLst>
-              </a:tr>
-              <a:tr h="598946">
-                <a:tc>
-                  <a:txBody>
-                    <a:bodyPr/>
-                    <a:lstStyle>
-                      <a:defPPr>
-                        <a:defRPr lang="es-ES"/>
-                      </a:defPPr>
-                    </a:lstStyle>
-                    <a:p>
-                      <a:pPr algn="ctr" rtl="0"/>
-                      <a:r>
-                        <a:rPr lang="es-ES" b="0" i="0">
-                          <a:latin typeface="+mn-lt"/>
-                        </a:rPr>
-                        <a:t>Retención de conocimientos</a:t>
-                      </a:r>
-                    </a:p>
-                  </a:txBody>
-                  <a:tcPr anchor="ctr"/>
-                </a:tc>
-                <a:tc>
-                  <a:txBody>
-                    <a:bodyPr/>
-                    <a:lstStyle>
-                      <a:defPPr>
-                        <a:defRPr lang="es-ES"/>
-                      </a:defPPr>
-                    </a:lstStyle>
-                    <a:p>
-                      <a:pPr algn="ctr" rtl="0"/>
-                      <a:r>
-                        <a:rPr lang="es-ES" b="0" i="0">
-                          <a:latin typeface="+mn-lt"/>
-                        </a:rPr>
-                        <a:t>Porcentaje (%)</a:t>
-                      </a:r>
-                    </a:p>
-                  </a:txBody>
-                  <a:tcPr anchor="ctr"/>
-                </a:tc>
-                <a:tc>
-                  <a:txBody>
-                    <a:bodyPr/>
-                    <a:lstStyle>
-                      <a:defPPr>
-                        <a:defRPr lang="es-ES"/>
-                      </a:defPPr>
-                    </a:lstStyle>
-                    <a:p>
-                      <a:pPr algn="ctr" rtl="0"/>
-                      <a:r>
-                        <a:rPr lang="es-ES" b="0" i="0">
-                          <a:latin typeface="+mn-lt"/>
-                        </a:rPr>
-                        <a:t>75</a:t>
-                      </a:r>
-                    </a:p>
-                  </a:txBody>
-                  <a:tcPr anchor="ctr"/>
-                </a:tc>
-                <a:tc>
-                  <a:txBody>
-                    <a:bodyPr/>
-                    <a:lstStyle>
-                      <a:defPPr>
-                        <a:defRPr lang="es-ES"/>
-                      </a:defPPr>
-                    </a:lstStyle>
-                    <a:p>
-                      <a:pPr algn="ctr" rtl="0"/>
-                      <a:r>
-                        <a:rPr lang="es-ES" b="0" i="0">
-                          <a:latin typeface="+mn-lt"/>
-                        </a:rPr>
-                        <a:t>80</a:t>
-                      </a:r>
-                    </a:p>
-                  </a:txBody>
-                  <a:tcPr anchor="ctr"/>
-                </a:tc>
-                <a:extLst>
-                  <a:ext uri="{0D108BD9-81ED-4DB2-BD59-A6C34878D82A}">
-                    <a16:rowId xmlns:a16="http://schemas.microsoft.com/office/drawing/2014/main" val="380626418"/>
-                  </a:ext>
-                </a:extLst>
-              </a:tr>
-              <a:tr h="615787">
-                <a:tc>
-                  <a:txBody>
-                    <a:bodyPr/>
-                    <a:lstStyle>
-                      <a:defPPr>
-                        <a:defRPr lang="es-ES"/>
-                      </a:defPPr>
-                    </a:lstStyle>
-                    <a:p>
-                      <a:pPr algn="ctr" rtl="0"/>
-                      <a:r>
-                        <a:rPr lang="es-ES" b="0" i="0">
-                          <a:latin typeface="+mn-lt"/>
-                        </a:rPr>
-                        <a:t>Encuestas posteriores a la presentación</a:t>
-                      </a:r>
-                    </a:p>
-                  </a:txBody>
-                  <a:tcPr anchor="ctr"/>
-                </a:tc>
-                <a:tc>
-                  <a:txBody>
-                    <a:bodyPr/>
-                    <a:lstStyle>
-                      <a:defPPr>
-                        <a:defRPr lang="es-ES"/>
-                      </a:defPPr>
-                    </a:lstStyle>
-                    <a:p>
-                      <a:pPr algn="ctr" rtl="0"/>
-                      <a:r>
-                        <a:rPr lang="es-ES" b="0" i="0">
-                          <a:latin typeface="+mn-lt"/>
-                        </a:rPr>
-                        <a:t>Clasificación media</a:t>
-                      </a:r>
-                    </a:p>
-                  </a:txBody>
-                  <a:tcPr anchor="ctr"/>
-                </a:tc>
-                <a:tc>
-                  <a:txBody>
-                    <a:bodyPr/>
-                    <a:lstStyle>
-                      <a:defPPr>
-                        <a:defRPr lang="es-ES"/>
-                      </a:defPPr>
-                    </a:lstStyle>
-                    <a:p>
-                      <a:pPr algn="ctr" rtl="0"/>
-                      <a:r>
-                        <a:rPr lang="es-ES" b="0" i="0" dirty="0">
-                          <a:latin typeface="+mn-lt"/>
-                        </a:rPr>
-                        <a:t>4,2</a:t>
-                      </a:r>
-                    </a:p>
-                  </a:txBody>
-                  <a:tcPr anchor="ctr"/>
-                </a:tc>
-                <a:tc>
-                  <a:txBody>
-                    <a:bodyPr/>
-                    <a:lstStyle>
-                      <a:defPPr>
-                        <a:defRPr lang="es-ES"/>
-                      </a:defPPr>
-                    </a:lstStyle>
-                    <a:p>
-                      <a:pPr algn="ctr" rtl="0"/>
-                      <a:r>
-                        <a:rPr lang="es-ES" b="0" i="0">
-                          <a:latin typeface="+mn-lt"/>
-                        </a:rPr>
-                        <a:t>4,5</a:t>
-                      </a:r>
-                    </a:p>
-                  </a:txBody>
-                  <a:tcPr anchor="ctr"/>
-                </a:tc>
-                <a:extLst>
-                  <a:ext uri="{0D108BD9-81ED-4DB2-BD59-A6C34878D82A}">
-                    <a16:rowId xmlns:a16="http://schemas.microsoft.com/office/drawing/2014/main" val="2132482967"/>
-                  </a:ext>
-                </a:extLst>
-              </a:tr>
-              <a:tr h="598946">
-                <a:tc>
-                  <a:txBody>
-                    <a:bodyPr/>
-                    <a:lstStyle>
-                      <a:defPPr>
-                        <a:defRPr lang="es-ES"/>
-                      </a:defPPr>
-                    </a:lstStyle>
-                    <a:p>
-                      <a:pPr algn="ctr" rtl="0"/>
-                      <a:r>
-                        <a:rPr lang="es-ES" b="0" i="0">
-                          <a:latin typeface="+mn-lt"/>
-                        </a:rPr>
-                        <a:t>Tasa de recomendación</a:t>
-                      </a:r>
-                    </a:p>
-                  </a:txBody>
-                  <a:tcPr anchor="ctr"/>
-                </a:tc>
-                <a:tc>
-                  <a:txBody>
-                    <a:bodyPr/>
-                    <a:lstStyle>
-                      <a:defPPr>
-                        <a:defRPr lang="es-ES"/>
-                      </a:defPPr>
-                    </a:lstStyle>
-                    <a:p>
-                      <a:pPr algn="ctr" rtl="0"/>
-                      <a:r>
-                        <a:rPr lang="es-ES" b="0" i="0">
-                          <a:latin typeface="+mn-lt"/>
-                        </a:rPr>
-                        <a:t>Porcentaje (%)</a:t>
-                      </a:r>
-                    </a:p>
-                  </a:txBody>
-                  <a:tcPr anchor="ctr"/>
-                </a:tc>
-                <a:tc>
-                  <a:txBody>
-                    <a:bodyPr/>
-                    <a:lstStyle>
-                      <a:defPPr>
-                        <a:defRPr lang="es-ES"/>
-                      </a:defPPr>
-                    </a:lstStyle>
-                    <a:p>
-                      <a:pPr algn="ctr" rtl="0"/>
-                      <a:r>
-                        <a:rPr lang="es-ES" b="0" i="0" dirty="0">
-                          <a:latin typeface="+mn-lt"/>
-                        </a:rPr>
-                        <a:t>10</a:t>
-                      </a:r>
-                    </a:p>
-                  </a:txBody>
-                  <a:tcPr anchor="ctr"/>
-                </a:tc>
-                <a:tc>
-                  <a:txBody>
-                    <a:bodyPr/>
-                    <a:lstStyle>
-                      <a:defPPr>
-                        <a:defRPr lang="es-ES"/>
-                      </a:defPPr>
-                    </a:lstStyle>
-                    <a:p>
-                      <a:pPr algn="ctr" rtl="0"/>
-                      <a:r>
-                        <a:rPr lang="es-ES" b="0" i="0">
-                          <a:latin typeface="+mn-lt"/>
-                        </a:rPr>
-                        <a:t>12</a:t>
-                      </a:r>
-                    </a:p>
-                  </a:txBody>
-                  <a:tcPr anchor="ctr"/>
-                </a:tc>
-                <a:extLst>
-                  <a:ext uri="{0D108BD9-81ED-4DB2-BD59-A6C34878D82A}">
-                    <a16:rowId xmlns:a16="http://schemas.microsoft.com/office/drawing/2014/main" val="3936251906"/>
-                  </a:ext>
-                </a:extLst>
-              </a:tr>
-              <a:tr h="615787">
-                <a:tc>
-                  <a:txBody>
-                    <a:bodyPr/>
-                    <a:lstStyle>
-                      <a:defPPr>
-                        <a:defRPr lang="es-ES"/>
-                      </a:defPPr>
-                    </a:lstStyle>
-                    <a:p>
-                      <a:pPr algn="ctr" rtl="0"/>
-                      <a:r>
-                        <a:rPr lang="es-ES" b="0" i="0" dirty="0">
-                          <a:latin typeface="+mn-lt"/>
-                        </a:rPr>
-                        <a:t>Oportunidades de colaboración</a:t>
-                      </a:r>
-                    </a:p>
-                  </a:txBody>
-                  <a:tcPr anchor="ctr"/>
-                </a:tc>
-                <a:tc>
-                  <a:txBody>
-                    <a:bodyPr/>
-                    <a:lstStyle>
-                      <a:defPPr>
-                        <a:defRPr lang="es-ES"/>
-                      </a:defPPr>
-                    </a:lstStyle>
-                    <a:p>
-                      <a:pPr algn="ctr" rtl="0"/>
-                      <a:r>
-                        <a:rPr lang="es-ES" b="0" i="0">
-                          <a:latin typeface="+mn-lt"/>
-                        </a:rPr>
-                        <a:t>N.º de oportunidades</a:t>
-                      </a:r>
-                    </a:p>
-                  </a:txBody>
-                  <a:tcPr anchor="ctr"/>
-                </a:tc>
-                <a:tc>
-                  <a:txBody>
-                    <a:bodyPr/>
-                    <a:lstStyle>
-                      <a:defPPr>
-                        <a:defRPr lang="es-ES"/>
-                      </a:defPPr>
-                    </a:lstStyle>
-                    <a:p>
-                      <a:pPr algn="ctr" rtl="0"/>
-                      <a:r>
-                        <a:rPr lang="es-ES" b="0" i="0">
-                          <a:latin typeface="+mn-lt"/>
-                        </a:rPr>
-                        <a:t>8</a:t>
-                      </a:r>
-                    </a:p>
-                  </a:txBody>
-                  <a:tcPr anchor="ctr"/>
-                </a:tc>
-                <a:tc>
-                  <a:txBody>
-                    <a:bodyPr/>
-                    <a:lstStyle>
-                      <a:defPPr>
-                        <a:defRPr lang="es-ES"/>
-                      </a:defPPr>
-                    </a:lstStyle>
-                    <a:p>
-                      <a:pPr algn="ctr" rtl="0"/>
-                      <a:r>
-                        <a:rPr lang="es-ES" b="0" i="0" dirty="0">
-                          <a:latin typeface="+mn-lt"/>
-                        </a:rPr>
-                        <a:t>10</a:t>
-                      </a:r>
-                    </a:p>
-                  </a:txBody>
-                  <a:tcPr anchor="ctr"/>
-                </a:tc>
-                <a:extLst>
-                  <a:ext uri="{0D108BD9-81ED-4DB2-BD59-A6C34878D82A}">
-                    <a16:rowId xmlns:a16="http://schemas.microsoft.com/office/drawing/2014/main" val="568537164"/>
-                  </a:ext>
-                </a:extLst>
-              </a:tr>
-            </a:tbl>
-          </a:graphicData>
-        </a:graphic>
-      </p:graphicFrame>
       <p:sp>
         <p:nvSpPr>
           <p:cNvPr id="3" name="Content Placeholder 2">
@@ -11885,7 +10287,7 @@
         </p:nvSpPr>
         <p:spPr>
           <a:xfrm>
-            <a:off x="457200" y="1600200"/>
+            <a:off x="749808" y="1545336"/>
             <a:ext cx="8229600" cy="4525963"/>
           </a:xfrm>
           <a:prstGeom prst="rect">
@@ -12060,49 +10462,48 @@
           </a:lstStyle>
           <a:p>
             <a:r>
-              <a:rPr lang="en-US"/>
+              <a:rPr lang="en-US" dirty="0"/>
               <a:t>Limitations:</a:t>
             </a:r>
           </a:p>
           <a:p>
             <a:r>
-              <a:rPr lang="en-US"/>
+              <a:rPr lang="en-US" dirty="0"/>
               <a:t>• Diagnostic-only DT</a:t>
             </a:r>
           </a:p>
           <a:p>
             <a:r>
-              <a:rPr lang="en-US"/>
+              <a:rPr lang="en-US" dirty="0"/>
               <a:t>• No predictive or prescriptive control</a:t>
             </a:r>
           </a:p>
           <a:p>
-            <a:endParaRPr lang="en-US"/>
-          </a:p>
-          <a:p>
-            <a:r>
-              <a:rPr lang="en-US"/>
+            <a:endParaRPr lang="en-US" dirty="0"/>
+          </a:p>
+          <a:p>
+            <a:r>
+              <a:rPr lang="en-US" dirty="0"/>
               <a:t>Next steps:</a:t>
             </a:r>
           </a:p>
           <a:p>
             <a:r>
-              <a:rPr lang="en-US"/>
+              <a:rPr lang="en-US" dirty="0"/>
               <a:t>• Forecasting</a:t>
             </a:r>
           </a:p>
           <a:p>
             <a:r>
-              <a:rPr lang="en-US"/>
+              <a:rPr lang="en-US" dirty="0"/>
               <a:t>• Anomaly detection</a:t>
             </a:r>
           </a:p>
           <a:p>
             <a:r>
-              <a:rPr lang="en-US"/>
+              <a:rPr lang="en-US" dirty="0"/>
               <a:t>• Alerting mechanisms</a:t>
             </a:r>
-            <a:endParaRPr lang="en-US" dirty="0"/>
           </a:p>
         </p:txBody>
       </p:sp>
@@ -12119,18 +10520,12 @@
 </p:sld>
 </file>
 
-<file path=ppt/slides/slide15.xml><?xml version="1.0" encoding="utf-8"?>
+<file path=ppt/slides/slide14.xml><?xml version="1.0" encoding="utf-8"?>
 <p:sld xmlns:a="http://schemas.openxmlformats.org/drawingml/2006/main" xmlns:r="http://schemas.openxmlformats.org/officeDocument/2006/relationships" xmlns:p="http://schemas.openxmlformats.org/presentationml/2006/main">
   <p:cSld>
     <p:spTree>
       <p:nvGrpSpPr>
-        <p:cNvPr id="1" name="">
-          <a:extLst>
-            <a:ext uri="{FF2B5EF4-FFF2-40B4-BE49-F238E27FC236}">
-              <a16:creationId xmlns:a16="http://schemas.microsoft.com/office/drawing/2014/main" id="{E7978EF4-BA5B-86E2-04CE-9CFF421F3A6A}"/>
-            </a:ext>
-          </a:extLst>
-        </p:cNvPr>
+        <p:cNvPr id="1" name=""/>
         <p:cNvGrpSpPr/>
         <p:nvPr/>
       </p:nvGrpSpPr>
@@ -12142,12 +10537,47 @@
           <a:chExt cx="0" cy="0"/>
         </a:xfrm>
       </p:grpSpPr>
+      <p:pic>
+        <p:nvPicPr>
+          <p:cNvPr id="34" name="Marcador de posición de imagen 5" descr="Primer plano de un puente con cables">
+            <a:extLst>
+              <a:ext uri="{FF2B5EF4-FFF2-40B4-BE49-F238E27FC236}">
+                <a16:creationId xmlns:a16="http://schemas.microsoft.com/office/drawing/2014/main" id="{E461669C-A7BA-D639-22CB-B5FBBE698B38}"/>
+              </a:ext>
+            </a:extLst>
+          </p:cNvPr>
+          <p:cNvPicPr>
+            <a:picLocks noGrp="1" noChangeAspect="1"/>
+          </p:cNvPicPr>
+          <p:nvPr>
+            <p:ph type="pic" sz="quarter" idx="10"/>
+          </p:nvPr>
+        </p:nvPicPr>
+        <p:blipFill rotWithShape="1">
+          <a:blip r:embed="rId3">
+            <a:extLst>
+              <a:ext uri="{28A0092B-C50C-407E-A947-70E740481C1C}">
+                <a14:useLocalDpi xmlns:a14="http://schemas.microsoft.com/office/drawing/2010/main" val="0"/>
+              </a:ext>
+            </a:extLst>
+          </a:blip>
+          <a:srcRect l="20" r="20"/>
+          <a:stretch/>
+        </p:blipFill>
+        <p:spPr>
+          <a:xfrm>
+            <a:off x="0" y="0"/>
+            <a:ext cx="5878987" cy="6857999"/>
+          </a:xfrm>
+          <a:noFill/>
+        </p:spPr>
+      </p:pic>
       <p:sp>
         <p:nvSpPr>
           <p:cNvPr id="2" name="Título 1">
             <a:extLst>
               <a:ext uri="{FF2B5EF4-FFF2-40B4-BE49-F238E27FC236}">
-                <a16:creationId xmlns:a16="http://schemas.microsoft.com/office/drawing/2014/main" id="{0A778970-DD54-6C8A-846A-24A8C9CA3AB5}"/>
+                <a16:creationId xmlns:a16="http://schemas.microsoft.com/office/drawing/2014/main" id="{28BAC361-0D7A-DC05-86B5-6DD77D322F5B}"/>
               </a:ext>
             </a:extLst>
           </p:cNvPr>
@@ -12160,27 +10590,23 @@
         </p:nvSpPr>
         <p:spPr>
           <a:xfrm>
-            <a:off x="838200" y="365126"/>
-            <a:ext cx="10515600" cy="650134"/>
+            <a:off x="9884896" y="3387037"/>
+            <a:ext cx="4902843" cy="3526778"/>
           </a:xfrm>
           <a:noFill/>
         </p:spPr>
         <p:txBody>
-          <a:bodyPr rtlCol="0"/>
+          <a:bodyPr rtlCol="0" anchor="b"/>
           <a:lstStyle>
             <a:defPPr>
               <a:defRPr lang="es-ES"/>
             </a:defPPr>
           </a:lstStyle>
           <a:p>
-            <a:pPr>
-              <a:lnSpc>
-                <a:spcPct val="110000"/>
-              </a:lnSpc>
-            </a:pPr>
-            <a:r>
-              <a:rPr lang="es-MX" dirty="0" err="1"/>
-              <a:t>Conclusion</a:t>
+            <a:pPr rtl="0"/>
+            <a:r>
+              <a:rPr lang="es-ES" dirty="0" err="1"/>
+              <a:t>Thanks</a:t>
             </a:r>
             <a:endParaRPr lang="es-ES" dirty="0"/>
           </a:p>
@@ -12188,10 +10614,10 @@
       </p:sp>
       <p:sp>
         <p:nvSpPr>
-          <p:cNvPr id="5" name="Content Placeholder 2">
-            <a:extLst>
-              <a:ext uri="{FF2B5EF4-FFF2-40B4-BE49-F238E27FC236}">
-                <a16:creationId xmlns:a16="http://schemas.microsoft.com/office/drawing/2014/main" id="{F4A405D5-22ED-B3C3-64DD-77CB6EEF69A8}"/>
+          <p:cNvPr id="4" name="Título 1">
+            <a:extLst>
+              <a:ext uri="{FF2B5EF4-FFF2-40B4-BE49-F238E27FC236}">
+                <a16:creationId xmlns:a16="http://schemas.microsoft.com/office/drawing/2014/main" id="{CB7D65FE-A573-7575-A7EA-D7703F2D0D67}"/>
               </a:ext>
             </a:extLst>
           </p:cNvPr>
@@ -12202,8 +10628,72 @@
         </p:nvSpPr>
         <p:spPr>
           <a:xfrm>
-            <a:off x="941832" y="1700252"/>
-            <a:ext cx="8229600" cy="4525963"/>
+            <a:off x="6752658" y="1188086"/>
+            <a:ext cx="3886767" cy="650134"/>
+          </a:xfrm>
+          <a:prstGeom prst="rect">
+            <a:avLst/>
+          </a:prstGeom>
+          <a:noFill/>
+        </p:spPr>
+        <p:txBody>
+          <a:bodyPr vert="horz" lIns="91440" tIns="45720" rIns="91440" bIns="45720" rtlCol="0" anchor="b">
+            <a:noAutofit/>
+          </a:bodyPr>
+          <a:lstStyle>
+            <a:defPPr>
+              <a:defRPr lang="es-ES"/>
+            </a:defPPr>
+            <a:lvl1pPr algn="l" defTabSz="914400" rtl="0" eaLnBrk="1" latinLnBrk="0" hangingPunct="1">
+              <a:lnSpc>
+                <a:spcPct val="90000"/>
+              </a:lnSpc>
+              <a:spcBef>
+                <a:spcPct val="0"/>
+              </a:spcBef>
+              <a:buNone/>
+              <a:defRPr lang="es-ES" sz="4000" i="1" kern="1200" cap="all" baseline="0">
+                <a:solidFill>
+                  <a:schemeClr val="accent1"/>
+                </a:solidFill>
+                <a:latin typeface="+mj-lt"/>
+                <a:ea typeface="+mj-ea"/>
+                <a:cs typeface="+mj-cs"/>
+              </a:defRPr>
+            </a:lvl1pPr>
+          </a:lstStyle>
+          <a:p>
+            <a:pPr>
+              <a:lnSpc>
+                <a:spcPct val="110000"/>
+              </a:lnSpc>
+            </a:pPr>
+            <a:r>
+              <a:rPr lang="es-MX" dirty="0" err="1"/>
+              <a:t>Conclusion</a:t>
+            </a:r>
+            <a:endParaRPr lang="es-MX" dirty="0"/>
+          </a:p>
+        </p:txBody>
+      </p:sp>
+      <p:sp>
+        <p:nvSpPr>
+          <p:cNvPr id="5" name="Content Placeholder 2">
+            <a:extLst>
+              <a:ext uri="{FF2B5EF4-FFF2-40B4-BE49-F238E27FC236}">
+                <a16:creationId xmlns:a16="http://schemas.microsoft.com/office/drawing/2014/main" id="{A93E4C14-1B3A-37EB-9F9F-C3B9F6679C0E}"/>
+              </a:ext>
+            </a:extLst>
+          </p:cNvPr>
+          <p:cNvSpPr txBox="1">
+            <a:spLocks/>
+          </p:cNvSpPr>
+          <p:nvPr/>
+        </p:nvSpPr>
+        <p:spPr>
+          <a:xfrm>
+            <a:off x="3918018" y="2887444"/>
+            <a:ext cx="8092440" cy="4525963"/>
           </a:xfrm>
           <a:prstGeom prst="rect">
             <a:avLst/>
@@ -12377,179 +10867,27 @@
           </a:lstStyle>
           <a:p>
             <a:r>
-              <a:rPr lang="en-US" dirty="0"/>
+              <a:rPr lang="en-US" sz="2400" dirty="0"/>
               <a:t>The project demonstrates a valid Digital Twin implementation.</a:t>
             </a:r>
           </a:p>
           <a:p>
-            <a:endParaRPr lang="en-US" dirty="0"/>
-          </a:p>
-          <a:p>
-            <a:r>
-              <a:rPr lang="en-US" dirty="0"/>
+            <a:endParaRPr lang="en-US" sz="2400" dirty="0"/>
+          </a:p>
+          <a:p>
+            <a:r>
+              <a:rPr lang="en-US" sz="2400" dirty="0"/>
               <a:t>It integrates data, models, and visualization to represent a real system.</a:t>
             </a:r>
           </a:p>
           <a:p>
-            <a:endParaRPr lang="en-US" dirty="0"/>
-          </a:p>
-          <a:p>
-            <a:r>
-              <a:rPr lang="en-US" dirty="0"/>
+            <a:endParaRPr lang="en-US" sz="2400" dirty="0"/>
+          </a:p>
+          <a:p>
+            <a:r>
+              <a:rPr lang="en-US" sz="2400" dirty="0"/>
               <a:t>Forms a foundation for advanced DT capabilities.</a:t>
             </a:r>
-          </a:p>
-        </p:txBody>
-      </p:sp>
-    </p:spTree>
-    <p:extLst>
-      <p:ext uri="{BB962C8B-B14F-4D97-AF65-F5344CB8AC3E}">
-        <p14:creationId xmlns:p14="http://schemas.microsoft.com/office/powerpoint/2010/main" val="3238683272"/>
-      </p:ext>
-    </p:extLst>
-  </p:cSld>
-  <p:clrMapOvr>
-    <a:masterClrMapping/>
-  </p:clrMapOvr>
-</p:sld>
-</file>
-
-<file path=ppt/slides/slide16.xml><?xml version="1.0" encoding="utf-8"?>
-<p:sld xmlns:a="http://schemas.openxmlformats.org/drawingml/2006/main" xmlns:r="http://schemas.openxmlformats.org/officeDocument/2006/relationships" xmlns:p="http://schemas.openxmlformats.org/presentationml/2006/main">
-  <p:cSld>
-    <p:spTree>
-      <p:nvGrpSpPr>
-        <p:cNvPr id="1" name=""/>
-        <p:cNvGrpSpPr/>
-        <p:nvPr/>
-      </p:nvGrpSpPr>
-      <p:grpSpPr>
-        <a:xfrm>
-          <a:off x="0" y="0"/>
-          <a:ext cx="0" cy="0"/>
-          <a:chOff x="0" y="0"/>
-          <a:chExt cx="0" cy="0"/>
-        </a:xfrm>
-      </p:grpSpPr>
-      <p:pic>
-        <p:nvPicPr>
-          <p:cNvPr id="34" name="Marcador de posición de imagen 5" descr="Primer plano de un puente con cables">
-            <a:extLst>
-              <a:ext uri="{FF2B5EF4-FFF2-40B4-BE49-F238E27FC236}">
-                <a16:creationId xmlns:a16="http://schemas.microsoft.com/office/drawing/2014/main" id="{E461669C-A7BA-D639-22CB-B5FBBE698B38}"/>
-              </a:ext>
-            </a:extLst>
-          </p:cNvPr>
-          <p:cNvPicPr>
-            <a:picLocks noGrp="1" noChangeAspect="1"/>
-          </p:cNvPicPr>
-          <p:nvPr>
-            <p:ph type="pic" sz="quarter" idx="10"/>
-          </p:nvPr>
-        </p:nvPicPr>
-        <p:blipFill rotWithShape="1">
-          <a:blip r:embed="rId3">
-            <a:extLst>
-              <a:ext uri="{28A0092B-C50C-407E-A947-70E740481C1C}">
-                <a14:useLocalDpi xmlns:a14="http://schemas.microsoft.com/office/drawing/2010/main" val="0"/>
-              </a:ext>
-            </a:extLst>
-          </a:blip>
-          <a:srcRect l="20" r="20"/>
-          <a:stretch/>
-        </p:blipFill>
-        <p:spPr>
-          <a:xfrm>
-            <a:off x="0" y="0"/>
-            <a:ext cx="7816995" cy="6858000"/>
-          </a:xfrm>
-          <a:noFill/>
-        </p:spPr>
-      </p:pic>
-      <p:sp>
-        <p:nvSpPr>
-          <p:cNvPr id="2" name="Título 1">
-            <a:extLst>
-              <a:ext uri="{FF2B5EF4-FFF2-40B4-BE49-F238E27FC236}">
-                <a16:creationId xmlns:a16="http://schemas.microsoft.com/office/drawing/2014/main" id="{28BAC361-0D7A-DC05-86B5-6DD77D322F5B}"/>
-              </a:ext>
-            </a:extLst>
-          </p:cNvPr>
-          <p:cNvSpPr>
-            <a:spLocks noGrp="1"/>
-          </p:cNvSpPr>
-          <p:nvPr>
-            <p:ph type="title"/>
-          </p:nvPr>
-        </p:nvSpPr>
-        <p:spPr>
-          <a:xfrm>
-            <a:off x="6080992" y="731562"/>
-            <a:ext cx="4902843" cy="3526778"/>
-          </a:xfrm>
-          <a:noFill/>
-        </p:spPr>
-        <p:txBody>
-          <a:bodyPr rtlCol="0" anchor="b"/>
-          <a:lstStyle>
-            <a:defPPr>
-              <a:defRPr lang="es-ES"/>
-            </a:defPPr>
-          </a:lstStyle>
-          <a:p>
-            <a:pPr rtl="0"/>
-            <a:r>
-              <a:rPr lang="es-ES" dirty="0" err="1"/>
-              <a:t>Thanks</a:t>
-            </a:r>
-            <a:endParaRPr lang="es-ES" dirty="0"/>
-          </a:p>
-        </p:txBody>
-      </p:sp>
-      <p:sp>
-        <p:nvSpPr>
-          <p:cNvPr id="3" name="Marcador de contenido 2">
-            <a:extLst>
-              <a:ext uri="{FF2B5EF4-FFF2-40B4-BE49-F238E27FC236}">
-                <a16:creationId xmlns:a16="http://schemas.microsoft.com/office/drawing/2014/main" id="{1BE98EFF-197D-3136-70B9-7BBD30A48931}"/>
-              </a:ext>
-            </a:extLst>
-          </p:cNvPr>
-          <p:cNvSpPr>
-            <a:spLocks noGrp="1"/>
-          </p:cNvSpPr>
-          <p:nvPr>
-            <p:ph idx="1"/>
-          </p:nvPr>
-        </p:nvSpPr>
-        <p:spPr>
-          <a:xfrm>
-            <a:off x="6080992" y="4373217"/>
-            <a:ext cx="4902843" cy="1753221"/>
-          </a:xfrm>
-          <a:noFill/>
-        </p:spPr>
-        <p:txBody>
-          <a:bodyPr rtlCol="0" anchor="t">
-            <a:normAutofit/>
-          </a:bodyPr>
-          <a:lstStyle>
-            <a:defPPr>
-              <a:defRPr lang="es-ES"/>
-            </a:defPPr>
-          </a:lstStyle>
-          <a:p>
-            <a:r>
-              <a:rPr lang="es-MX" dirty="0"/>
-              <a:t>Harold Stiven Vargas H.</a:t>
-            </a:r>
-          </a:p>
-          <a:p>
-            <a:r>
-              <a:rPr lang="es-MX" dirty="0"/>
-              <a:t>Wilson Santiago Bonilla G.</a:t>
-            </a:r>
-            <a:endParaRPr lang="es-ES" dirty="0"/>
           </a:p>
         </p:txBody>
       </p:sp>
@@ -13532,7 +11870,7 @@
         <p:spPr>
           <a:xfrm>
             <a:off x="1316736" y="1938528"/>
-            <a:ext cx="8229600" cy="4525963"/>
+            <a:ext cx="9418320" cy="4525963"/>
           </a:xfrm>
           <a:prstGeom prst="rect">
             <a:avLst/>
@@ -13711,145 +12049,145 @@
           </a:lstStyle>
           <a:p>
             <a:r>
-              <a:rPr lang="es-MX" dirty="0" err="1"/>
+              <a:rPr lang="es-MX" sz="2400" dirty="0" err="1"/>
               <a:t>Physical</a:t>
             </a:r>
             <a:r>
-              <a:rPr lang="es-MX" dirty="0"/>
+              <a:rPr lang="es-MX" sz="2400" dirty="0"/>
               <a:t> </a:t>
             </a:r>
             <a:r>
-              <a:rPr lang="es-MX" dirty="0" err="1"/>
+              <a:rPr lang="es-MX" sz="2400" dirty="0" err="1"/>
               <a:t>system</a:t>
             </a:r>
             <a:r>
-              <a:rPr lang="es-MX" dirty="0"/>
+              <a:rPr lang="es-MX" sz="2400" dirty="0"/>
               <a:t>: A </a:t>
             </a:r>
             <a:r>
-              <a:rPr lang="es-MX" dirty="0" err="1"/>
+              <a:rPr lang="es-MX" sz="2400" dirty="0" err="1"/>
               <a:t>computing</a:t>
             </a:r>
             <a:r>
-              <a:rPr lang="es-MX" dirty="0"/>
+              <a:rPr lang="es-MX" sz="2400" dirty="0"/>
               <a:t> </a:t>
             </a:r>
             <a:r>
-              <a:rPr lang="es-MX" dirty="0" err="1"/>
+              <a:rPr lang="es-MX" sz="2400" dirty="0" err="1"/>
               <a:t>node</a:t>
             </a:r>
             <a:r>
-              <a:rPr lang="es-MX" dirty="0"/>
+              <a:rPr lang="es-MX" sz="2400" dirty="0"/>
               <a:t> (PC/server).</a:t>
             </a:r>
           </a:p>
           <a:p>
-            <a:endParaRPr lang="es-MX" dirty="0"/>
-          </a:p>
-          <a:p>
-            <a:r>
-              <a:rPr lang="es-MX" dirty="0" err="1"/>
+            <a:endParaRPr lang="es-MX" sz="2400" dirty="0"/>
+          </a:p>
+          <a:p>
+            <a:r>
+              <a:rPr lang="es-MX" sz="2400" dirty="0" err="1"/>
               <a:t>Objective</a:t>
             </a:r>
             <a:r>
-              <a:rPr lang="es-MX" dirty="0"/>
+              <a:rPr lang="es-MX" sz="2400" dirty="0"/>
               <a:t>: </a:t>
             </a:r>
             <a:r>
-              <a:rPr lang="es-MX" dirty="0" err="1"/>
+              <a:rPr lang="es-MX" sz="2400" dirty="0" err="1"/>
               <a:t>Create</a:t>
             </a:r>
             <a:r>
-              <a:rPr lang="es-MX" dirty="0"/>
+              <a:rPr lang="es-MX" sz="2400" dirty="0"/>
               <a:t> a </a:t>
             </a:r>
             <a:r>
-              <a:rPr lang="es-MX" dirty="0" err="1"/>
+              <a:rPr lang="es-MX" sz="2400" dirty="0" err="1"/>
               <a:t>diagnostic</a:t>
             </a:r>
             <a:r>
-              <a:rPr lang="es-MX" dirty="0"/>
+              <a:rPr lang="es-MX" sz="2400" dirty="0"/>
               <a:t> Digital Twin </a:t>
             </a:r>
             <a:r>
-              <a:rPr lang="es-MX" dirty="0" err="1"/>
+              <a:rPr lang="es-MX" sz="2400" dirty="0" err="1"/>
               <a:t>to</a:t>
             </a:r>
             <a:r>
-              <a:rPr lang="es-MX" dirty="0"/>
+              <a:rPr lang="es-MX" sz="2400" dirty="0"/>
               <a:t> observe, </a:t>
             </a:r>
             <a:r>
-              <a:rPr lang="es-MX" dirty="0" err="1"/>
+              <a:rPr lang="es-MX" sz="2400" dirty="0" err="1"/>
               <a:t>analyze</a:t>
             </a:r>
             <a:r>
-              <a:rPr lang="es-MX" dirty="0"/>
+              <a:rPr lang="es-MX" sz="2400" dirty="0"/>
               <a:t>, and </a:t>
             </a:r>
             <a:r>
-              <a:rPr lang="es-MX" dirty="0" err="1"/>
+              <a:rPr lang="es-MX" sz="2400" dirty="0" err="1"/>
               <a:t>understand</a:t>
             </a:r>
             <a:r>
-              <a:rPr lang="es-MX" dirty="0"/>
+              <a:rPr lang="es-MX" sz="2400" dirty="0"/>
               <a:t> </a:t>
             </a:r>
             <a:r>
-              <a:rPr lang="es-MX" dirty="0" err="1"/>
+              <a:rPr lang="es-MX" sz="2400" dirty="0" err="1"/>
               <a:t>system</a:t>
             </a:r>
             <a:r>
-              <a:rPr lang="es-MX" dirty="0"/>
+              <a:rPr lang="es-MX" sz="2400" dirty="0"/>
               <a:t> performance </a:t>
             </a:r>
             <a:r>
-              <a:rPr lang="es-MX" dirty="0" err="1"/>
+              <a:rPr lang="es-MX" sz="2400" dirty="0" err="1"/>
               <a:t>dynamics</a:t>
             </a:r>
             <a:r>
-              <a:rPr lang="es-MX" dirty="0"/>
+              <a:rPr lang="es-MX" sz="2400" dirty="0"/>
               <a:t>.</a:t>
             </a:r>
           </a:p>
           <a:p>
-            <a:endParaRPr lang="es-MX" dirty="0"/>
-          </a:p>
-          <a:p>
-            <a:r>
-              <a:rPr lang="es-MX" dirty="0"/>
+            <a:endParaRPr lang="es-MX" sz="2400" dirty="0"/>
+          </a:p>
+          <a:p>
+            <a:r>
+              <a:rPr lang="es-MX" sz="2400" dirty="0"/>
               <a:t>Focus </a:t>
             </a:r>
             <a:r>
-              <a:rPr lang="es-MX" dirty="0" err="1"/>
+              <a:rPr lang="es-MX" sz="2400" dirty="0" err="1"/>
               <a:t>is</a:t>
             </a:r>
             <a:r>
-              <a:rPr lang="es-MX" dirty="0"/>
+              <a:rPr lang="es-MX" sz="2400" dirty="0"/>
               <a:t> </a:t>
             </a:r>
             <a:r>
-              <a:rPr lang="es-MX" dirty="0" err="1"/>
+              <a:rPr lang="es-MX" sz="2400" dirty="0" err="1"/>
               <a:t>diagnostic</a:t>
             </a:r>
             <a:r>
-              <a:rPr lang="es-MX" dirty="0"/>
+              <a:rPr lang="es-MX" sz="2400" dirty="0"/>
               <a:t> and </a:t>
             </a:r>
             <a:r>
-              <a:rPr lang="es-MX" dirty="0" err="1"/>
+              <a:rPr lang="es-MX" sz="2400" dirty="0" err="1"/>
               <a:t>analytical</a:t>
             </a:r>
             <a:r>
-              <a:rPr lang="es-MX" dirty="0"/>
+              <a:rPr lang="es-MX" sz="2400" dirty="0"/>
               <a:t>, </a:t>
             </a:r>
             <a:r>
-              <a:rPr lang="es-MX" dirty="0" err="1"/>
+              <a:rPr lang="es-MX" sz="2400" dirty="0" err="1"/>
               <a:t>not</a:t>
             </a:r>
             <a:r>
-              <a:rPr lang="es-MX" dirty="0"/>
+              <a:rPr lang="es-MX" sz="2400" dirty="0"/>
               <a:t> control.</a:t>
             </a:r>
           </a:p>
@@ -15008,7 +13346,7 @@
         </p:nvSpPr>
         <p:spPr>
           <a:xfrm>
-            <a:off x="457200" y="1600200"/>
+            <a:off x="1490472" y="1938528"/>
             <a:ext cx="8229600" cy="4525963"/>
           </a:xfrm>
           <a:prstGeom prst="rect">
@@ -15360,10 +13698,343 @@
       </p:grpSpPr>
       <p:sp>
         <p:nvSpPr>
-          <p:cNvPr id="2" name="Título 1">
-            <a:extLst>
-              <a:ext uri="{FF2B5EF4-FFF2-40B4-BE49-F238E27FC236}">
-                <a16:creationId xmlns:a16="http://schemas.microsoft.com/office/drawing/2014/main" id="{338A15DE-D135-0710-9984-A0A55E960CB0}"/>
+          <p:cNvPr id="5" name="Add-in_Banner">
+            <a:extLst>
+              <a:ext uri="{FF2B5EF4-FFF2-40B4-BE49-F238E27FC236}">
+                <a16:creationId xmlns:a16="http://schemas.microsoft.com/office/drawing/2014/main" id="{3A30FB22-F368-4CB2-D391-EC21745707D5}"/>
+              </a:ext>
+            </a:extLst>
+          </p:cNvPr>
+          <p:cNvSpPr txBox="1">
+            <a:spLocks/>
+          </p:cNvSpPr>
+          <p:nvPr/>
+        </p:nvSpPr>
+        <p:spPr>
+          <a:xfrm>
+            <a:off x="-493776" y="945499"/>
+            <a:ext cx="12192000" cy="640515"/>
+          </a:xfrm>
+          <a:prstGeom prst="rect">
+            <a:avLst/>
+          </a:prstGeom>
+          <a:solidFill>
+            <a:srgbClr val="494748">
+              <a:alpha val="4706"/>
+            </a:srgbClr>
+          </a:solidFill>
+          <a:ln w="19050" cap="flat" cmpd="sng" algn="ctr">
+            <a:noFill/>
+            <a:prstDash val="solid"/>
+            <a:miter lim="800000"/>
+          </a:ln>
+        </p:spPr>
+        <p:style>
+          <a:lnRef idx="2">
+            <a:schemeClr val="accent1">
+              <a:shade val="50000"/>
+            </a:schemeClr>
+          </a:lnRef>
+          <a:fillRef idx="1">
+            <a:schemeClr val="accent1"/>
+          </a:fillRef>
+          <a:effectRef idx="0">
+            <a:schemeClr val="accent1"/>
+          </a:effectRef>
+          <a:fontRef idx="minor">
+            <a:schemeClr val="lt1"/>
+          </a:fontRef>
+        </p:style>
+        <p:txBody>
+          <a:bodyPr rot="0" spcFirstLastPara="0" vert="horz" wrap="square" lIns="1332000" tIns="180000" rIns="216000" bIns="180000" numCol="1" spcCol="0" rtlCol="0" fromWordArt="0" anchor="ctr" anchorCtr="0" forceAA="0" compatLnSpc="1">
+            <a:prstTxWarp prst="textNoShape">
+              <a:avLst/>
+            </a:prstTxWarp>
+            <a:spAutoFit/>
+          </a:bodyPr>
+          <a:lstStyle>
+            <a:defPPr>
+              <a:defRPr lang="es-ES"/>
+            </a:defPPr>
+            <a:lvl1pPr algn="l" defTabSz="914400" rtl="0" eaLnBrk="1" latinLnBrk="0" hangingPunct="1">
+              <a:lnSpc>
+                <a:spcPct val="90000"/>
+              </a:lnSpc>
+              <a:spcBef>
+                <a:spcPct val="0"/>
+              </a:spcBef>
+              <a:buNone/>
+              <a:defRPr lang="es-ES" sz="3600" i="1" kern="1200" cap="all" baseline="0">
+                <a:solidFill>
+                  <a:schemeClr val="lt1"/>
+                </a:solidFill>
+                <a:latin typeface="+mn-lt"/>
+                <a:ea typeface="+mn-ea"/>
+                <a:cs typeface="+mn-cs"/>
+              </a:defRPr>
+            </a:lvl1pPr>
+            <a:lvl2pPr>
+              <a:defRPr>
+                <a:solidFill>
+                  <a:schemeClr val="lt1"/>
+                </a:solidFill>
+                <a:latin typeface="+mn-lt"/>
+                <a:ea typeface="+mn-ea"/>
+                <a:cs typeface="+mn-cs"/>
+              </a:defRPr>
+            </a:lvl2pPr>
+            <a:lvl3pPr>
+              <a:defRPr>
+                <a:solidFill>
+                  <a:schemeClr val="lt1"/>
+                </a:solidFill>
+                <a:latin typeface="+mn-lt"/>
+                <a:ea typeface="+mn-ea"/>
+                <a:cs typeface="+mn-cs"/>
+              </a:defRPr>
+            </a:lvl3pPr>
+            <a:lvl4pPr>
+              <a:defRPr>
+                <a:solidFill>
+                  <a:schemeClr val="lt1"/>
+                </a:solidFill>
+                <a:latin typeface="+mn-lt"/>
+                <a:ea typeface="+mn-ea"/>
+                <a:cs typeface="+mn-cs"/>
+              </a:defRPr>
+            </a:lvl4pPr>
+            <a:lvl5pPr>
+              <a:defRPr>
+                <a:solidFill>
+                  <a:schemeClr val="lt1"/>
+                </a:solidFill>
+                <a:latin typeface="+mn-lt"/>
+                <a:ea typeface="+mn-ea"/>
+                <a:cs typeface="+mn-cs"/>
+              </a:defRPr>
+            </a:lvl5pPr>
+            <a:lvl6pPr>
+              <a:defRPr>
+                <a:solidFill>
+                  <a:schemeClr val="lt1"/>
+                </a:solidFill>
+                <a:latin typeface="+mn-lt"/>
+                <a:ea typeface="+mn-ea"/>
+                <a:cs typeface="+mn-cs"/>
+              </a:defRPr>
+            </a:lvl6pPr>
+            <a:lvl7pPr>
+              <a:defRPr>
+                <a:solidFill>
+                  <a:schemeClr val="lt1"/>
+                </a:solidFill>
+                <a:latin typeface="+mn-lt"/>
+                <a:ea typeface="+mn-ea"/>
+                <a:cs typeface="+mn-cs"/>
+              </a:defRPr>
+            </a:lvl7pPr>
+            <a:lvl8pPr>
+              <a:defRPr>
+                <a:solidFill>
+                  <a:schemeClr val="lt1"/>
+                </a:solidFill>
+                <a:latin typeface="+mn-lt"/>
+                <a:ea typeface="+mn-ea"/>
+                <a:cs typeface="+mn-cs"/>
+              </a:defRPr>
+            </a:lvl8pPr>
+            <a:lvl9pPr>
+              <a:defRPr>
+                <a:solidFill>
+                  <a:schemeClr val="lt1"/>
+                </a:solidFill>
+                <a:latin typeface="+mn-lt"/>
+                <a:ea typeface="+mn-ea"/>
+                <a:cs typeface="+mn-cs"/>
+              </a:defRPr>
+            </a:lvl9pPr>
+          </a:lstStyle>
+          <a:p>
+            <a:r>
+              <a:rPr lang="en-GB" sz="1800" dirty="0">
+                <a:solidFill>
+                  <a:srgbClr val="000000"/>
+                </a:solidFill>
+                <a:latin typeface="Segoe UI Light" panose="020B0502040204020203" pitchFamily="34" charset="0"/>
+                <a:ea typeface="Calibri" panose="020F0502020204030204" pitchFamily="34" charset="0"/>
+                <a:cs typeface="Segoe UI Light" panose="020B0502040204020203" pitchFamily="34" charset="0"/>
+              </a:rPr>
+              <a:t>Microsoft Power BI</a:t>
+            </a:r>
+            <a:endParaRPr lang="en-IE" sz="1200" dirty="0">
+              <a:latin typeface="Segoe UI Light" panose="020B0502040204020203" pitchFamily="34" charset="0"/>
+              <a:ea typeface="Calibri" panose="020F0502020204030204" pitchFamily="34" charset="0"/>
+              <a:cs typeface="Segoe UI Light" panose="020B0502040204020203" pitchFamily="34" charset="0"/>
+            </a:endParaRPr>
+          </a:p>
+        </p:txBody>
+      </p:sp>
+      <p:pic>
+        <p:nvPicPr>
+          <p:cNvPr id="6" name="Add-in_Icon" descr="Icono de Microsoft Power BI.">
+            <a:extLst>
+              <a:ext uri="{FF2B5EF4-FFF2-40B4-BE49-F238E27FC236}">
+                <a16:creationId xmlns:a16="http://schemas.microsoft.com/office/drawing/2014/main" id="{925F527C-0053-D686-AAEA-6F2B90C47242}"/>
+              </a:ext>
+            </a:extLst>
+          </p:cNvPr>
+          <p:cNvPicPr/>
+          <p:nvPr/>
+        </p:nvPicPr>
+        <p:blipFill>
+          <a:blip r:embed="rId3"/>
+          <a:stretch>
+            <a:fillRect/>
+          </a:stretch>
+        </p:blipFill>
+        <p:spPr bwMode="auto">
+          <a:xfrm>
+            <a:off x="293751" y="1120023"/>
+            <a:ext cx="291465" cy="291465"/>
+          </a:xfrm>
+          <a:prstGeom prst="rect">
+            <a:avLst/>
+          </a:prstGeom>
+          <a:noFill/>
+        </p:spPr>
+      </p:pic>
+      <mc:AlternateContent xmlns:mc="http://schemas.openxmlformats.org/markup-compatibility/2006">
+        <mc:Choice xmlns:we="http://schemas.microsoft.com/office/webextensions/webextension/2010/11" xmlns:pca="http://schemas.microsoft.com/office/powerpoint/2013/contentapp" Requires="we pca">
+          <p:graphicFrame>
+            <p:nvGraphicFramePr>
+              <p:cNvPr id="7" name="Add-in" descr="Contenido de complemento para Microsoft Power BI.">
+                <a:extLst>
+                  <a:ext uri="{FF2B5EF4-FFF2-40B4-BE49-F238E27FC236}">
+                    <a16:creationId xmlns:a16="http://schemas.microsoft.com/office/drawing/2014/main" id="{7451A9BC-A222-E697-B28C-B1BF2517B1F6}"/>
+                  </a:ext>
+                </a:extLst>
+              </p:cNvPr>
+              <p:cNvGraphicFramePr>
+                <a:graphicFrameLocks noGrp="1"/>
+              </p:cNvGraphicFramePr>
+              <p:nvPr>
+                <p:extLst>
+                  <p:ext uri="{D42A27DB-BD31-4B8C-83A1-F6EECF244321}">
+                    <p14:modId xmlns:p14="http://schemas.microsoft.com/office/powerpoint/2010/main" val="3856306045"/>
+                  </p:ext>
+                </p:extLst>
+              </p:nvPr>
+            </p:nvGraphicFramePr>
+            <p:xfrm>
+              <a:off x="3218689" y="945499"/>
+              <a:ext cx="8973312" cy="5451377"/>
+            </p:xfrm>
+            <a:graphic>
+              <a:graphicData uri="http://schemas.microsoft.com/office/webextensions/webextension/2010/11">
+                <we:webextensionref xmlns:we="http://schemas.microsoft.com/office/webextensions/webextension/2010/11" xmlns:r="http://schemas.openxmlformats.org/officeDocument/2006/relationships" r:id="rId4"/>
+              </a:graphicData>
+            </a:graphic>
+          </p:graphicFrame>
+        </mc:Choice>
+        <mc:Fallback>
+          <p:pic>
+            <p:nvPicPr>
+              <p:cNvPr id="7" name="Add-in" descr="Contenido de complemento para Microsoft Power BI.">
+                <a:extLst>
+                  <a:ext uri="{FF2B5EF4-FFF2-40B4-BE49-F238E27FC236}">
+                    <a16:creationId xmlns:a16="http://schemas.microsoft.com/office/drawing/2014/main" id="{7451A9BC-A222-E697-B28C-B1BF2517B1F6}"/>
+                  </a:ext>
+                </a:extLst>
+              </p:cNvPr>
+              <p:cNvPicPr>
+                <a:picLocks noGrp="1" noRot="1" noChangeAspect="1" noMove="1" noResize="1" noEditPoints="1" noAdjustHandles="1" noChangeArrowheads="1" noChangeShapeType="1"/>
+              </p:cNvPicPr>
+              <p:nvPr/>
+            </p:nvPicPr>
+            <p:blipFill>
+              <a:blip r:embed="rId5"/>
+              <a:stretch>
+                <a:fillRect/>
+              </a:stretch>
+            </p:blipFill>
+            <p:spPr>
+              <a:xfrm>
+                <a:off x="3218689" y="945499"/>
+                <a:ext cx="8973312" cy="5451377"/>
+              </a:xfrm>
+              <a:prstGeom prst="rect">
+                <a:avLst/>
+              </a:prstGeom>
+            </p:spPr>
+          </p:pic>
+        </mc:Fallback>
+      </mc:AlternateContent>
+      <p:sp>
+        <p:nvSpPr>
+          <p:cNvPr id="2" name="Content Placeholder 2">
+            <a:extLst>
+              <a:ext uri="{FF2B5EF4-FFF2-40B4-BE49-F238E27FC236}">
+                <a16:creationId xmlns:a16="http://schemas.microsoft.com/office/drawing/2014/main" id="{83638BE6-32FE-8516-CBD9-008470A926EB}"/>
+              </a:ext>
+            </a:extLst>
+          </p:cNvPr>
+          <p:cNvSpPr>
+            <a:spLocks noGrp="1"/>
+          </p:cNvSpPr>
+          <p:nvPr>
+            <p:ph idx="1"/>
+          </p:nvPr>
+        </p:nvSpPr>
+        <p:spPr>
+          <a:xfrm>
+            <a:off x="585216" y="1709684"/>
+            <a:ext cx="2304288" cy="4038657"/>
+          </a:xfrm>
+        </p:spPr>
+        <p:txBody>
+          <a:bodyPr/>
+          <a:lstStyle/>
+          <a:p>
+            <a:r>
+              <a:rPr dirty="0"/>
+              <a:t>Power BI dashboard visualizes:</a:t>
+            </a:r>
+          </a:p>
+          <a:p>
+            <a:r>
+              <a:rPr dirty="0"/>
+              <a:t>• Resource utilization over time</a:t>
+            </a:r>
+          </a:p>
+          <a:p>
+            <a:r>
+              <a:rPr dirty="0"/>
+              <a:t>• Peak events</a:t>
+            </a:r>
+          </a:p>
+          <a:p>
+            <a:r>
+              <a:rPr dirty="0"/>
+              <a:t>• System state evolution</a:t>
+            </a:r>
+          </a:p>
+          <a:p>
+            <a:endParaRPr dirty="0"/>
+          </a:p>
+          <a:p>
+            <a:r>
+              <a:rPr dirty="0"/>
+              <a:t>Used for monitoring and diagnostic insight.</a:t>
+            </a:r>
+          </a:p>
+        </p:txBody>
+      </p:sp>
+      <p:sp>
+        <p:nvSpPr>
+          <p:cNvPr id="3" name="Título 1">
+            <a:extLst>
+              <a:ext uri="{FF2B5EF4-FFF2-40B4-BE49-F238E27FC236}">
+                <a16:creationId xmlns:a16="http://schemas.microsoft.com/office/drawing/2014/main" id="{445BA989-B814-A028-1F5D-E087C89D36B0}"/>
               </a:ext>
             </a:extLst>
           </p:cNvPr>
@@ -15376,7 +14047,7 @@
         </p:nvSpPr>
         <p:spPr>
           <a:xfrm>
-            <a:off x="838201" y="-375539"/>
+            <a:off x="2977897" y="-503734"/>
             <a:ext cx="6645965" cy="1325563"/>
           </a:xfrm>
           <a:noFill/>
@@ -15410,106 +14081,10 @@
           </a:p>
         </p:txBody>
       </p:sp>
-      <p:pic>
-        <p:nvPicPr>
-          <p:cNvPr id="20" name="Marcador de posición de imagen 19" descr="Luces de la ciudad por la noche">
-            <a:extLst>
-              <a:ext uri="{FF2B5EF4-FFF2-40B4-BE49-F238E27FC236}">
-                <a16:creationId xmlns:a16="http://schemas.microsoft.com/office/drawing/2014/main" id="{E5D7764F-CE06-1A00-3555-ACAE6ACDFE10}"/>
-              </a:ext>
-            </a:extLst>
-          </p:cNvPr>
-          <p:cNvPicPr>
-            <a:picLocks noGrp="1" noChangeAspect="1"/>
-          </p:cNvPicPr>
-          <p:nvPr>
-            <p:ph type="pic" sz="quarter" idx="13"/>
-          </p:nvPr>
-        </p:nvPicPr>
-        <p:blipFill>
-          <a:blip r:embed="rId3">
-            <a:extLst>
-              <a:ext uri="{28A0092B-C50C-407E-A947-70E740481C1C}">
-                <a14:useLocalDpi xmlns:a14="http://schemas.microsoft.com/office/drawing/2010/main" val="0"/>
-              </a:ext>
-            </a:extLst>
-          </a:blip>
-          <a:srcRect l="44379" t="236" r="26690" b="-132"/>
-          <a:stretch>
-            <a:fillRect/>
-          </a:stretch>
-        </p:blipFill>
-        <p:spPr>
-          <a:xfrm>
-            <a:off x="10863072" y="-22860"/>
-            <a:ext cx="1338072" cy="6903720"/>
-          </a:xfrm>
-        </p:spPr>
-      </p:pic>
-      <p:sp>
-        <p:nvSpPr>
-          <p:cNvPr id="6" name="Content Placeholder 2">
-            <a:extLst>
-              <a:ext uri="{FF2B5EF4-FFF2-40B4-BE49-F238E27FC236}">
-                <a16:creationId xmlns:a16="http://schemas.microsoft.com/office/drawing/2014/main" id="{6569191B-8D85-24E4-5B07-58C733D0479B}"/>
-              </a:ext>
-            </a:extLst>
-          </p:cNvPr>
-          <p:cNvSpPr>
-            <a:spLocks noGrp="1"/>
-          </p:cNvSpPr>
-          <p:nvPr>
-            <p:ph idx="1"/>
-          </p:nvPr>
-        </p:nvSpPr>
-        <p:spPr>
-          <a:xfrm>
-            <a:off x="685800" y="1636776"/>
-            <a:ext cx="8229600" cy="4525963"/>
-          </a:xfrm>
-        </p:spPr>
-        <p:txBody>
-          <a:bodyPr/>
-          <a:lstStyle/>
-          <a:p>
-            <a:r>
-              <a:rPr dirty="0"/>
-              <a:t>Power BI dashboard visualizes:</a:t>
-            </a:r>
-          </a:p>
-          <a:p>
-            <a:r>
-              <a:rPr dirty="0"/>
-              <a:t>• Resource utilization over time</a:t>
-            </a:r>
-          </a:p>
-          <a:p>
-            <a:r>
-              <a:rPr dirty="0"/>
-              <a:t>• Peak events</a:t>
-            </a:r>
-          </a:p>
-          <a:p>
-            <a:r>
-              <a:rPr dirty="0"/>
-              <a:t>• System state evolution</a:t>
-            </a:r>
-          </a:p>
-          <a:p>
-            <a:endParaRPr dirty="0"/>
-          </a:p>
-          <a:p>
-            <a:r>
-              <a:rPr dirty="0"/>
-              <a:t>Used for monitoring and diagnostic insight.</a:t>
-            </a:r>
-          </a:p>
-        </p:txBody>
-      </p:sp>
     </p:spTree>
     <p:extLst>
       <p:ext uri="{BB962C8B-B14F-4D97-AF65-F5344CB8AC3E}">
-        <p14:creationId xmlns:p14="http://schemas.microsoft.com/office/powerpoint/2010/main" val="2737241225"/>
+        <p14:creationId xmlns:p14="http://schemas.microsoft.com/office/powerpoint/2010/main" val="4112581839"/>
       </p:ext>
     </p:extLst>
   </p:cSld>
@@ -16358,7 +14933,7 @@
     <we:property name="Microsoft.Office.CampaignId" value="&quot;none&quot;"/>
     <we:property name="artifactViewState" value="&quot;live&quot;"/>
     <we:property name="backgroundColor" value="&quot;#FFFFFF&quot;"/>
-    <we:property name="bookmark" value="&quot;H4sIAAAAAAAAA+VZ32/bNhD+VwK99MUtSFGSJb+lbgYUbQYjyfoyBMaRPDlqZUmgqCxekP+9R9FGt9StE6PJrEyAYel4uh/fd0dS0m2gi7YpYfU7LDGYBKdgFOjaHPFgFFRehnmk4yxDFo7HoWYYjjXQaN3Yoq7aYHIbWDALtJ+KtoPSGSLhn4GUmAlUqWJpFsdRIqI0Ci5HAZTlDBZOJ4eyxVHQoGnrCsrib/QmaMiaDu9GAd40ZW3AOTq3YNE5uyZ1uqbA+BtBcYCyxTWeo7JeGqdJKHgSyjRhEWMJsLEktdYr9PFuVXGme/fTurJQVOTGybamQfK8KO1GZXVy0xjKmZBYNQ6yKcW6qE2hoAz6LAy2PujbYFqX3bI/O/mX/LzujMIzzPuhyhZ2RZbaVWtxOV+iJWvtXIOFFm1wR+DMTE3Q9Vq2INAtLJv5sqg6wsmNX9V/TQ1SJDqYsLtLkrRFtSjXIH/L98LHbEGWeHLjmJWfCSyXGt1TG43m7arP7l1hNjDz0b3wnymtPo+rYnFV0s86my2Wm6AoRGfpFJp+YKuPN98Zdbe1ipy+1z6RZQOmaDdpba4+FJUDchR8xNw+K5Fnm1Q/FlRynrpPUHaONbKD7qZXPM2y1zx8LdgFYxORTBh75fDyiJFbcC4p2UsSkESGGvIwyTMZSqYSkIKpnXV9rK+hUlRQ94v6eLEwuAC7vnz60lBNN6dzhZUf+q2rNpW5R+0rMHo99LDyD++X/2EB4CkWoVS5UImQLE5VglHM2IAoNrCcdy3q/zfPu1HwZEOMCYcx5ynLeAxCqDQcENmP6ufRIS+0owNElzZ5Xx7ZS4eYxhPMCCVt9KZXYOzB73s2O13S+/yPvey6A3ygzxQMTTikk2oRRankiqYdWlnGKk1hQDPOHj3xEteXB8DgF5gskjIMMxYyhkpphIQNie4fLzDRMCa/XUQNJI0dc/iWLHZ3XdmRZ4Pax/uY6fy/77+f1qXvPI5ai1xFUcKVjBnEPBnSPv5RnfcSp9gHUJzmUsgoYiqOxykyzpXAAVH8FE09PJ53o+DJzqMQZBymkYhTFFqzjMkBkb3HQvQS2X4ADJ5uFauEi5zFLE2Qx4oOvj/dpwhtZ/DX5jJD+HI0nf1xdEGb/f2eaZ8urnfvzz8cZGBnx6c/iuvXF/x3D57PUgj9o57T+RZisESz6N3WnW0bUDiDyr9Fb7yhAns9ogEqjXp9btz/ljfY/VegzZtqOr4C/FSTR5MaAAA=&quot;"/>
+    <we:property name="bookmark" value="&quot;H4sIAAAAAAAAA+VZ32/bNhD+VwK99MUtSFGSJb9lbgYUbQYjyfoyFMaRPDlqZUmgqCxekP+9R9FCtzSdE6PJrMyAYfF4uh/fd0dS8k2gi7YpYfMbrDGYBadgFOjaHPFgElRelmRRlOc8iachRiBRoWQ0Wze2qKs2mN0EFswK7cei7aB0hkj4x6dJAGW5gJUb5VC2OAkaNG1dQVn8hV6Zpqzp8HYS4HVT1gacyXMLFp3ZK1KnMYXA3wjyCMoWV3iOynppnCah4Eko04RFjCXAppLUWq/QR3avijPdu5/XlYWiIjdOJiVmAlWqWJrFcZSIKI2cPC9KO6hsTq4bQ9lRzpvGgTOnWFe1KRSUQZ+FwdYHfRPM67Jb91cn/5Cf151ReIZ5P1XZwm7IUrtpLa6Xa7RkrV1qsNCiDW4JnIWpCbpeyxYEr4V1s1wXVUc4ufnL+s+5QYpEBzN2+4kkbVGtyi3I3/K98DFbkCWeXDsO5WcCy6VG99RGo/ll02f3tjADzHxyJ/xnSqvP47JYXZb0tc5mi+UQFIXoLJ1C00/c6+PNd0bdba0ip++0T2TdgCnaIa1h9L6oHJCT4APm9lmJPBtS/VBQyXnqPkLZOdbIDrqbXvE0y17z8LVgF4zNxHTG2CuHl0eM3IJz6VqQBCSRoYY8TPJMhpKpBKRgamddH+srqBQV1N2iPl6tDK7AbodPXxqq6ZZ0rbDyU7921VCZe9S+AqO3Uw8r//Bu+R8WAJ5iEUqVC5UIyeJUJRjFjI2IYgPrZdei/n/zvBsFTzbEmHCYcp6yjMcghErDEZH9qH6eHPJGOzlAdOk49+WRvXSIaTzBilDSQW9+CcYe/LlnOOmS3ue/nWW3HeADfaZgaMEhnVSLKEolV7Ts0M4yVWkKI1px9uiJl7i/PAAGv8FkkZRhmLGQMVRKIyRsTHT/eIOJxrH47SJqJGnsWMPvyWJ315UdeTaofbyPWc7/+/7717r0ncdRa5GrKEq4kjGDmCdjOsc/qvNe4hL7AIrTXAoZRUzF8TRFxrkSOCKKn6Kpx8fzbhQ82XkUgozDNBJxikJrljE5IrL32IheItsPgMHTrWKVcJGzmKUJ8ljRh+9P9ylC2xn8ubksEL4czRe/H13QYX+/Z9qni+vtu/P3BxnY2fHpj+L6+QX/3YPnsxRC/6jndL6FGKzRrHq3dWfbBhQuoPJv0RtvqMBej2iASqPeXhv3e88b7P5foOFNNX2+Ao5C63Z9GgAA&quot;"/>
     <we:property name="creatorSessionId" value="&quot;9b0c294c-6b84-4425-ad55-a3254678cebd&quot;"/>
     <we:property name="creatorTenantId" value="&quot;aca51631-00fe-490d-91ab-163ef87260ee&quot;"/>
     <we:property name="creatorUserId" value="&quot;1003200216764C2C&quot;"/>
@@ -16380,6 +14955,15 @@
 </file>
 
 <file path=customXml/item1.xml><?xml version="1.0" encoding="utf-8"?>
+<?mso-contentType ?>
+<FormTemplates xmlns="http://schemas.microsoft.com/sharepoint/v3/contenttype/forms">
+  <Display>DocumentLibraryForm</Display>
+  <Edit>DocumentLibraryForm</Edit>
+  <New>DocumentLibraryForm</New>
+</FormTemplates>
+</file>
+
+<file path=customXml/item2.xml><?xml version="1.0" encoding="utf-8"?>
 <p:properties xmlns:p="http://schemas.microsoft.com/office/2006/metadata/properties" xmlns:xsi="http://www.w3.org/2001/XMLSchema-instance" xmlns:pc="http://schemas.microsoft.com/office/infopath/2007/PartnerControls">
   <documentManagement>
     <_ip_UnifiedCompliancePolicyUIAction xmlns="http://schemas.microsoft.com/sharepoint/v3" xsi:nil="true"/>
@@ -16397,15 +14981,6 @@
     <MediaServiceKeyPoints xmlns="71af3243-3dd4-4a8d-8c0d-dd76da1f02a5" xsi:nil="true"/>
   </documentManagement>
 </p:properties>
-</file>
-
-<file path=customXml/item2.xml><?xml version="1.0" encoding="utf-8"?>
-<?mso-contentType ?>
-<FormTemplates xmlns="http://schemas.microsoft.com/sharepoint/v3/contenttype/forms">
-  <Display>DocumentLibraryForm</Display>
-  <Edit>DocumentLibraryForm</Edit>
-  <New>DocumentLibraryForm</New>
-</FormTemplates>
 </file>
 
 <file path=customXml/item3.xml><?xml version="1.0" encoding="utf-8"?>
@@ -16721,6 +15296,14 @@
 </file>
 
 <file path=customXml/itemProps1.xml><?xml version="1.0" encoding="utf-8"?>
+<ds:datastoreItem xmlns:ds="http://schemas.openxmlformats.org/officeDocument/2006/customXml" ds:itemID="{24D4B218-C04B-41F5-949D-06E9DAE96B0A}">
+  <ds:schemaRefs>
+    <ds:schemaRef ds:uri="http://schemas.microsoft.com/sharepoint/v3/contenttype/forms"/>
+  </ds:schemaRefs>
+</ds:datastoreItem>
+</file>
+
+<file path=customXml/itemProps2.xml><?xml version="1.0" encoding="utf-8"?>
 <ds:datastoreItem xmlns:ds="http://schemas.openxmlformats.org/officeDocument/2006/customXml" ds:itemID="{B6283731-47E9-4F14-86D1-57C1EA2672A1}">
   <ds:schemaRefs>
     <ds:schemaRef ds:uri="http://schemas.microsoft.com/office/2006/metadata/properties"/>
@@ -16728,14 +15311,6 @@
     <ds:schemaRef ds:uri="http://schemas.microsoft.com/sharepoint/v3"/>
     <ds:schemaRef ds:uri="71af3243-3dd4-4a8d-8c0d-dd76da1f02a5"/>
     <ds:schemaRef ds:uri="230e9df3-be65-4c73-a93b-d1236ebd677e"/>
-  </ds:schemaRefs>
-</ds:datastoreItem>
-</file>
-
-<file path=customXml/itemProps2.xml><?xml version="1.0" encoding="utf-8"?>
-<ds:datastoreItem xmlns:ds="http://schemas.openxmlformats.org/officeDocument/2006/customXml" ds:itemID="{24D4B218-C04B-41F5-949D-06E9DAE96B0A}">
-  <ds:schemaRefs>
-    <ds:schemaRef ds:uri="http://schemas.microsoft.com/sharepoint/v3/contenttype/forms"/>
   </ds:schemaRefs>
 </ds:datastoreItem>
 </file>

</xml_diff>